<commit_message>
Finalize poster references and methods
</commit_message>
<xml_diff>
--- a/poster/BMI6313_TEFCA_Poster_Jordan_Pulaski.pptx
+++ b/poster/BMI6313_TEFCA_Poster_Jordan_Pulaski.pptx
@@ -221,6 +221,227 @@
     </p:ext>
   </p:extLst>
 </p:presentation>
+</file>
+
+<file path=ppt/revisionInfo.xml><?xml version="1.0" encoding="utf-8"?>
+<p1510:revInfo xmlns:a="http://schemas.openxmlformats.org/drawingml/2006/main" xmlns:r="http://schemas.openxmlformats.org/officeDocument/2006/relationships" xmlns:p1510="http://schemas.microsoft.com/office/powerpoint/2015/10/main">
+  <p1510:revLst>
+    <p1510:client id="{ECF8852F-3FCF-4736-A5DC-07A8B6B99125}" v="16" dt="2026-07-27T21:13:31.040"/>
+  </p1510:revLst>
+</p1510:revInfo>
+</file>
+
+<file path=ppt/changesInfos/changesInfo1.xml><?xml version="1.0" encoding="utf-8"?>
+<pc:chgInfo xmlns:a="http://schemas.openxmlformats.org/drawingml/2006/main" xmlns:r="http://schemas.openxmlformats.org/officeDocument/2006/relationships" xmlns:ac="http://schemas.microsoft.com/office/drawing/2013/main/command" xmlns:pc="http://schemas.microsoft.com/office/powerpoint/2013/main/command">
+  <pc:docChgLst>
+    <pc:chgData name="Pulaski, Jordan A" userId="b59e5678-eb70-4bba-8605-0c3b286199fc" providerId="ADAL" clId="{ECF8852F-3FCF-4736-A5DC-07A8B6B99125}"/>
+    <pc:docChg chg="undo redo custSel modSld">
+      <pc:chgData name="Pulaski, Jordan A" userId="b59e5678-eb70-4bba-8605-0c3b286199fc" providerId="ADAL" clId="{ECF8852F-3FCF-4736-A5DC-07A8B6B99125}" dt="2026-07-27T21:18:49.644" v="400" actId="20577"/>
+      <pc:docMkLst>
+        <pc:docMk/>
+      </pc:docMkLst>
+      <pc:sldChg chg="addSp delSp modSp mod">
+        <pc:chgData name="Pulaski, Jordan A" userId="b59e5678-eb70-4bba-8605-0c3b286199fc" providerId="ADAL" clId="{ECF8852F-3FCF-4736-A5DC-07A8B6B99125}" dt="2026-07-27T21:18:49.644" v="400" actId="20577"/>
+        <pc:sldMkLst>
+          <pc:docMk/>
+          <pc:sldMk cId="0" sldId="256"/>
+        </pc:sldMkLst>
+        <pc:spChg chg="mod">
+          <ac:chgData name="Pulaski, Jordan A" userId="b59e5678-eb70-4bba-8605-0c3b286199fc" providerId="ADAL" clId="{ECF8852F-3FCF-4736-A5DC-07A8B6B99125}" dt="2026-07-27T20:41:04.191" v="160" actId="255"/>
+          <ac:spMkLst>
+            <pc:docMk/>
+            <pc:sldMk cId="0" sldId="256"/>
+            <ac:spMk id="11" creationId="{5B86F263-CCBD-8F74-7C4A-DA7AE3E35802}"/>
+          </ac:spMkLst>
+        </pc:spChg>
+        <pc:spChg chg="mod">
+          <ac:chgData name="Pulaski, Jordan A" userId="b59e5678-eb70-4bba-8605-0c3b286199fc" providerId="ADAL" clId="{ECF8852F-3FCF-4736-A5DC-07A8B6B99125}" dt="2026-07-27T20:36:35.512" v="147" actId="1076"/>
+          <ac:spMkLst>
+            <pc:docMk/>
+            <pc:sldMk cId="0" sldId="256"/>
+            <ac:spMk id="16" creationId="{74FE048F-31DE-1509-501D-9CA3376B31BF}"/>
+          </ac:spMkLst>
+        </pc:spChg>
+        <pc:spChg chg="mod">
+          <ac:chgData name="Pulaski, Jordan A" userId="b59e5678-eb70-4bba-8605-0c3b286199fc" providerId="ADAL" clId="{ECF8852F-3FCF-4736-A5DC-07A8B6B99125}" dt="2026-07-27T20:41:07.598" v="161" actId="255"/>
+          <ac:spMkLst>
+            <pc:docMk/>
+            <pc:sldMk cId="0" sldId="256"/>
+            <ac:spMk id="18" creationId="{4D8920F3-11E9-EDDF-8C4B-DD0C8E7CB750}"/>
+          </ac:spMkLst>
+        </pc:spChg>
+        <pc:spChg chg="mod">
+          <ac:chgData name="Pulaski, Jordan A" userId="b59e5678-eb70-4bba-8605-0c3b286199fc" providerId="ADAL" clId="{ECF8852F-3FCF-4736-A5DC-07A8B6B99125}" dt="2026-07-27T21:18:42.669" v="398" actId="20577"/>
+          <ac:spMkLst>
+            <pc:docMk/>
+            <pc:sldMk cId="0" sldId="256"/>
+            <ac:spMk id="21" creationId="{00000000-0000-0000-0000-000000000000}"/>
+          </ac:spMkLst>
+        </pc:spChg>
+        <pc:spChg chg="mod">
+          <ac:chgData name="Pulaski, Jordan A" userId="b59e5678-eb70-4bba-8605-0c3b286199fc" providerId="ADAL" clId="{ECF8852F-3FCF-4736-A5DC-07A8B6B99125}" dt="2026-07-27T20:40:34.675" v="157" actId="1076"/>
+          <ac:spMkLst>
+            <pc:docMk/>
+            <pc:sldMk cId="0" sldId="256"/>
+            <ac:spMk id="25" creationId="{00000000-0000-0000-0000-000000000000}"/>
+          </ac:spMkLst>
+        </pc:spChg>
+        <pc:spChg chg="mod">
+          <ac:chgData name="Pulaski, Jordan A" userId="b59e5678-eb70-4bba-8605-0c3b286199fc" providerId="ADAL" clId="{ECF8852F-3FCF-4736-A5DC-07A8B6B99125}" dt="2026-07-27T20:49:51.204" v="218" actId="14100"/>
+          <ac:spMkLst>
+            <pc:docMk/>
+            <pc:sldMk cId="0" sldId="256"/>
+            <ac:spMk id="27" creationId="{00000000-0000-0000-0000-000000000000}"/>
+          </ac:spMkLst>
+        </pc:spChg>
+        <pc:spChg chg="mod">
+          <ac:chgData name="Pulaski, Jordan A" userId="b59e5678-eb70-4bba-8605-0c3b286199fc" providerId="ADAL" clId="{ECF8852F-3FCF-4736-A5DC-07A8B6B99125}" dt="2026-07-27T21:03:13.694" v="230"/>
+          <ac:spMkLst>
+            <pc:docMk/>
+            <pc:sldMk cId="0" sldId="256"/>
+            <ac:spMk id="30" creationId="{00000000-0000-0000-0000-000000000000}"/>
+          </ac:spMkLst>
+        </pc:spChg>
+        <pc:spChg chg="mod">
+          <ac:chgData name="Pulaski, Jordan A" userId="b59e5678-eb70-4bba-8605-0c3b286199fc" providerId="ADAL" clId="{ECF8852F-3FCF-4736-A5DC-07A8B6B99125}" dt="2026-07-27T20:48:21.032" v="208" actId="14100"/>
+          <ac:spMkLst>
+            <pc:docMk/>
+            <pc:sldMk cId="0" sldId="256"/>
+            <ac:spMk id="33" creationId="{00000000-0000-0000-0000-000000000000}"/>
+          </ac:spMkLst>
+        </pc:spChg>
+        <pc:spChg chg="mod">
+          <ac:chgData name="Pulaski, Jordan A" userId="b59e5678-eb70-4bba-8605-0c3b286199fc" providerId="ADAL" clId="{ECF8852F-3FCF-4736-A5DC-07A8B6B99125}" dt="2026-07-27T21:14:23.637" v="362" actId="1076"/>
+          <ac:spMkLst>
+            <pc:docMk/>
+            <pc:sldMk cId="0" sldId="256"/>
+            <ac:spMk id="34" creationId="{00000000-0000-0000-0000-000000000000}"/>
+          </ac:spMkLst>
+        </pc:spChg>
+        <pc:spChg chg="mod">
+          <ac:chgData name="Pulaski, Jordan A" userId="b59e5678-eb70-4bba-8605-0c3b286199fc" providerId="ADAL" clId="{ECF8852F-3FCF-4736-A5DC-07A8B6B99125}" dt="2026-07-27T21:18:49.644" v="400" actId="20577"/>
+          <ac:spMkLst>
+            <pc:docMk/>
+            <pc:sldMk cId="0" sldId="256"/>
+            <ac:spMk id="35" creationId="{00000000-0000-0000-0000-000000000000}"/>
+          </ac:spMkLst>
+        </pc:spChg>
+        <pc:spChg chg="mod">
+          <ac:chgData name="Pulaski, Jordan A" userId="b59e5678-eb70-4bba-8605-0c3b286199fc" providerId="ADAL" clId="{ECF8852F-3FCF-4736-A5DC-07A8B6B99125}" dt="2026-07-27T21:04:10.194" v="234" actId="14100"/>
+          <ac:spMkLst>
+            <pc:docMk/>
+            <pc:sldMk cId="0" sldId="256"/>
+            <ac:spMk id="36" creationId="{00000000-0000-0000-0000-000000000000}"/>
+          </ac:spMkLst>
+        </pc:spChg>
+        <pc:spChg chg="mod">
+          <ac:chgData name="Pulaski, Jordan A" userId="b59e5678-eb70-4bba-8605-0c3b286199fc" providerId="ADAL" clId="{ECF8852F-3FCF-4736-A5DC-07A8B6B99125}" dt="2026-07-27T20:40:52.590" v="159" actId="255"/>
+          <ac:spMkLst>
+            <pc:docMk/>
+            <pc:sldMk cId="0" sldId="256"/>
+            <ac:spMk id="61" creationId="{2EDA1001-BDAB-96D5-C6E6-759B2635D8C1}"/>
+          </ac:spMkLst>
+        </pc:spChg>
+        <pc:spChg chg="mod">
+          <ac:chgData name="Pulaski, Jordan A" userId="b59e5678-eb70-4bba-8605-0c3b286199fc" providerId="ADAL" clId="{ECF8852F-3FCF-4736-A5DC-07A8B6B99125}" dt="2026-07-27T20:50:29.901" v="222" actId="1076"/>
+          <ac:spMkLst>
+            <pc:docMk/>
+            <pc:sldMk cId="0" sldId="256"/>
+            <ac:spMk id="1025" creationId="{1A4C4739-BF4A-89E8-7CF5-5DB5D1B45FAE}"/>
+          </ac:spMkLst>
+        </pc:spChg>
+        <pc:spChg chg="mod">
+          <ac:chgData name="Pulaski, Jordan A" userId="b59e5678-eb70-4bba-8605-0c3b286199fc" providerId="ADAL" clId="{ECF8852F-3FCF-4736-A5DC-07A8B6B99125}" dt="2026-07-27T21:14:38.167" v="363" actId="1076"/>
+          <ac:spMkLst>
+            <pc:docMk/>
+            <pc:sldMk cId="0" sldId="256"/>
+            <ac:spMk id="1033" creationId="{FDB23A6E-5FE5-7133-FBB7-85483EC23619}"/>
+          </ac:spMkLst>
+        </pc:spChg>
+        <pc:spChg chg="mod">
+          <ac:chgData name="Pulaski, Jordan A" userId="b59e5678-eb70-4bba-8605-0c3b286199fc" providerId="ADAL" clId="{ECF8852F-3FCF-4736-A5DC-07A8B6B99125}" dt="2026-07-27T20:41:27.079" v="163" actId="1076"/>
+          <ac:spMkLst>
+            <pc:docMk/>
+            <pc:sldMk cId="0" sldId="256"/>
+            <ac:spMk id="1039" creationId="{E0E0A4BE-228B-5BEB-54BA-52C613362C28}"/>
+          </ac:spMkLst>
+        </pc:spChg>
+        <pc:spChg chg="mod">
+          <ac:chgData name="Pulaski, Jordan A" userId="b59e5678-eb70-4bba-8605-0c3b286199fc" providerId="ADAL" clId="{ECF8852F-3FCF-4736-A5DC-07A8B6B99125}" dt="2026-07-27T20:36:40.596" v="148" actId="14100"/>
+          <ac:spMkLst>
+            <pc:docMk/>
+            <pc:sldMk cId="0" sldId="256"/>
+            <ac:spMk id="1052" creationId="{ECAF7F30-4242-F28F-CC63-2CF9D23A54BF}"/>
+          </ac:spMkLst>
+        </pc:spChg>
+        <pc:spChg chg="add del mod">
+          <ac:chgData name="Pulaski, Jordan A" userId="b59e5678-eb70-4bba-8605-0c3b286199fc" providerId="ADAL" clId="{ECF8852F-3FCF-4736-A5DC-07A8B6B99125}" dt="2026-07-27T21:04:33.784" v="258" actId="478"/>
+          <ac:spMkLst>
+            <pc:docMk/>
+            <pc:sldMk cId="0" sldId="256"/>
+            <ac:spMk id="1066" creationId="{A9AC913A-78A9-B672-DD13-D3B761320305}"/>
+          </ac:spMkLst>
+        </pc:spChg>
+        <pc:spChg chg="add mod">
+          <ac:chgData name="Pulaski, Jordan A" userId="b59e5678-eb70-4bba-8605-0c3b286199fc" providerId="ADAL" clId="{ECF8852F-3FCF-4736-A5DC-07A8B6B99125}" dt="2026-07-27T21:11:39.113" v="345" actId="1076"/>
+          <ac:spMkLst>
+            <pc:docMk/>
+            <pc:sldMk cId="0" sldId="256"/>
+            <ac:spMk id="1067" creationId="{90FF7E03-AF81-5A22-01FA-EF6B8005E07B}"/>
+          </ac:spMkLst>
+        </pc:spChg>
+        <pc:spChg chg="add del mod">
+          <ac:chgData name="Pulaski, Jordan A" userId="b59e5678-eb70-4bba-8605-0c3b286199fc" providerId="ADAL" clId="{ECF8852F-3FCF-4736-A5DC-07A8B6B99125}" dt="2026-07-27T21:06:54.980" v="266" actId="478"/>
+          <ac:spMkLst>
+            <pc:docMk/>
+            <pc:sldMk cId="0" sldId="256"/>
+            <ac:spMk id="1068" creationId="{09C5D111-8D29-EF8E-7EC6-17FA88828792}"/>
+          </ac:spMkLst>
+        </pc:spChg>
+        <pc:spChg chg="add mod">
+          <ac:chgData name="Pulaski, Jordan A" userId="b59e5678-eb70-4bba-8605-0c3b286199fc" providerId="ADAL" clId="{ECF8852F-3FCF-4736-A5DC-07A8B6B99125}" dt="2026-07-27T21:13:31.038" v="360" actId="1076"/>
+          <ac:spMkLst>
+            <pc:docMk/>
+            <pc:sldMk cId="0" sldId="256"/>
+            <ac:spMk id="1069" creationId="{1119BEB3-184E-0733-EF53-DC6A69720D61}"/>
+          </ac:spMkLst>
+        </pc:spChg>
+        <pc:spChg chg="mod">
+          <ac:chgData name="Pulaski, Jordan A" userId="b59e5678-eb70-4bba-8605-0c3b286199fc" providerId="ADAL" clId="{ECF8852F-3FCF-4736-A5DC-07A8B6B99125}" dt="2026-07-27T20:34:21.247" v="132" actId="1076"/>
+          <ac:spMkLst>
+            <pc:docMk/>
+            <pc:sldMk cId="0" sldId="256"/>
+            <ac:spMk id="2051" creationId="{00000000-0000-0000-0000-000000000000}"/>
+          </ac:spMkLst>
+        </pc:spChg>
+        <pc:spChg chg="mod">
+          <ac:chgData name="Pulaski, Jordan A" userId="b59e5678-eb70-4bba-8605-0c3b286199fc" providerId="ADAL" clId="{ECF8852F-3FCF-4736-A5DC-07A8B6B99125}" dt="2026-07-27T20:36:46.429" v="149" actId="14100"/>
+          <ac:spMkLst>
+            <pc:docMk/>
+            <pc:sldMk cId="0" sldId="256"/>
+            <ac:spMk id="2057" creationId="{00000000-0000-0000-0000-000000000000}"/>
+          </ac:spMkLst>
+        </pc:spChg>
+        <pc:picChg chg="mod">
+          <ac:chgData name="Pulaski, Jordan A" userId="b59e5678-eb70-4bba-8605-0c3b286199fc" providerId="ADAL" clId="{ECF8852F-3FCF-4736-A5DC-07A8B6B99125}" dt="2026-07-27T20:34:08.153" v="130" actId="14100"/>
+          <ac:picMkLst>
+            <pc:docMk/>
+            <pc:sldMk cId="0" sldId="256"/>
+            <ac:picMk id="2" creationId="{00000000-0000-0000-0000-000000000000}"/>
+          </ac:picMkLst>
+        </pc:picChg>
+        <pc:picChg chg="mod">
+          <ac:chgData name="Pulaski, Jordan A" userId="b59e5678-eb70-4bba-8605-0c3b286199fc" providerId="ADAL" clId="{ECF8852F-3FCF-4736-A5DC-07A8B6B99125}" dt="2026-07-27T20:48:10.069" v="207" actId="1076"/>
+          <ac:picMkLst>
+            <pc:docMk/>
+            <pc:sldMk cId="0" sldId="256"/>
+            <ac:picMk id="1064" creationId="{5D15A370-C4E4-A783-B6E2-F2E3FA2DD4C1}"/>
+          </ac:picMkLst>
+        </pc:picChg>
+      </pc:sldChg>
+    </pc:docChg>
+  </pc:docChgLst>
+</pc:chgInfo>
 </file>
 
 <file path=ppt/notesMasters/notesMaster1.xml><?xml version="1.0" encoding="utf-8"?>
@@ -4028,8 +4249,8 @@
         </p:nvSpPr>
         <p:spPr bwMode="auto">
           <a:xfrm>
-            <a:off x="365760" y="12287718"/>
-            <a:ext cx="13350240" cy="2496881"/>
+            <a:off x="329374" y="12617129"/>
+            <a:ext cx="13322618" cy="2167470"/>
           </a:xfrm>
           <a:prstGeom prst="rect">
             <a:avLst/>
@@ -4099,7 +4320,7 @@
         <p:spPr bwMode="auto">
           <a:xfrm>
             <a:off x="33147000" y="15653358"/>
-            <a:ext cx="9939528" cy="11550042"/>
+            <a:ext cx="9939528" cy="6955300"/>
           </a:xfrm>
           <a:prstGeom prst="rect">
             <a:avLst/>
@@ -4243,7 +4464,7 @@
         <p:spPr>
           <a:xfrm>
             <a:off x="914400" y="248488"/>
-            <a:ext cx="5486400" cy="5480913"/>
+            <a:ext cx="4917421" cy="4912503"/>
           </a:xfrm>
           <a:prstGeom prst="rect">
             <a:avLst/>
@@ -4301,8 +4522,8 @@
         </p:nvSpPr>
         <p:spPr bwMode="auto">
           <a:xfrm>
-            <a:off x="587828" y="14859000"/>
-            <a:ext cx="20671971" cy="794358"/>
+            <a:off x="329374" y="14859000"/>
+            <a:ext cx="20930425" cy="794358"/>
           </a:xfrm>
           <a:prstGeom prst="rect">
             <a:avLst/>
@@ -4538,8 +4759,8 @@
         </p:nvSpPr>
         <p:spPr bwMode="auto">
           <a:xfrm>
-            <a:off x="26517600" y="5279824"/>
-            <a:ext cx="16568928" cy="808278"/>
+            <a:off x="29632703" y="5279824"/>
+            <a:ext cx="13453824" cy="801867"/>
           </a:xfrm>
           <a:prstGeom prst="rect">
             <a:avLst/>
@@ -4596,8 +4817,8 @@
         </p:nvSpPr>
         <p:spPr bwMode="auto">
           <a:xfrm>
-            <a:off x="26462255" y="6341858"/>
-            <a:ext cx="8458200" cy="5857283"/>
+            <a:off x="29654543" y="6087637"/>
+            <a:ext cx="6714697" cy="7426943"/>
           </a:xfrm>
           <a:prstGeom prst="rect">
             <a:avLst/>
@@ -4662,8 +4883,8 @@
         </p:nvSpPr>
         <p:spPr bwMode="auto">
           <a:xfrm>
-            <a:off x="365760" y="5954714"/>
-            <a:ext cx="13350240" cy="808277"/>
+            <a:off x="365760" y="5290931"/>
+            <a:ext cx="13578840" cy="794358"/>
           </a:xfrm>
           <a:prstGeom prst="rect">
             <a:avLst/>
@@ -4713,7 +4934,7 @@
         <p:spPr bwMode="auto">
           <a:xfrm>
             <a:off x="14173200" y="5281083"/>
-            <a:ext cx="11887200" cy="794358"/>
+            <a:ext cx="15122516" cy="794358"/>
           </a:xfrm>
           <a:prstGeom prst="rect">
             <a:avLst/>
@@ -4770,8 +4991,8 @@
         </p:nvSpPr>
         <p:spPr bwMode="auto">
           <a:xfrm>
-            <a:off x="14109192" y="11915390"/>
-            <a:ext cx="11887200" cy="2841073"/>
+            <a:off x="14263394" y="10867370"/>
+            <a:ext cx="15032322" cy="4018318"/>
           </a:xfrm>
           <a:prstGeom prst="rect">
             <a:avLst/>
@@ -4796,14 +5017,14 @@
               </a:spcBef>
             </a:pPr>
             <a:r>
-              <a:rPr lang="en-US" sz="2800" b="1" dirty="0">
+              <a:rPr lang="en-US" sz="2700" b="1" dirty="0">
                 <a:latin typeface="Arial" pitchFamily="34" charset="0"/>
                 <a:cs typeface="Arial" pitchFamily="34" charset="0"/>
               </a:rPr>
               <a:t>Figure 1. </a:t>
             </a:r>
             <a:r>
-              <a:rPr lang="en-US" sz="2800" dirty="0">
+              <a:rPr lang="en-US" sz="2700" dirty="0">
                 <a:latin typeface="Arial" pitchFamily="34" charset="0"/>
                 <a:cs typeface="Arial" pitchFamily="34" charset="0"/>
               </a:rPr>
@@ -4817,18 +5038,53 @@
               </a:spcBef>
             </a:pPr>
             <a:r>
-              <a:rPr lang="en-US" sz="3200" dirty="0">
+              <a:rPr lang="en-US" sz="3400" dirty="0">
                 <a:latin typeface="Arial" pitchFamily="34" charset="0"/>
                 <a:cs typeface="Arial" pitchFamily="34" charset="0"/>
               </a:rPr>
-              <a:t>Models adjusted for national-network, EHR vendor-network, and HIO participation; log CMS denominator; state; and survey year</a:t>
-            </a:r>
-            <a:r>
-              <a:rPr lang="en-US" sz="2600" dirty="0">
+              <a:t>Hospital-level ONC survey data (2023–2024)</a:t>
+            </a:r>
+            <a:r>
+              <a:rPr lang="en-US" sz="3400" baseline="30000" dirty="0">
                 <a:latin typeface="Arial" pitchFamily="34" charset="0"/>
                 <a:cs typeface="Arial" pitchFamily="34" charset="0"/>
               </a:rPr>
-              <a:t>.</a:t>
+              <a:t>12</a:t>
+            </a:r>
+            <a:r>
+              <a:rPr lang="en-US" sz="3400" dirty="0">
+                <a:latin typeface="Arial" pitchFamily="34" charset="0"/>
+                <a:cs typeface="Arial" pitchFamily="34" charset="0"/>
+              </a:rPr>
+              <a:t> were linked to CMS Hybrid HWM data (7/1/2023–6/30/2024) and heart failure/pneumonia mortality data </a:t>
+            </a:r>
+            <a:r>
+              <a:rPr lang="en-US" sz="3400">
+                <a:latin typeface="Arial" pitchFamily="34" charset="0"/>
+                <a:cs typeface="Arial" pitchFamily="34" charset="0"/>
+              </a:rPr>
+              <a:t>(7/1/2021–6/30/2024).</a:t>
+            </a:r>
+            <a:r>
+              <a:rPr lang="en-US" sz="3400" baseline="30000">
+                <a:latin typeface="Arial" pitchFamily="34" charset="0"/>
+                <a:cs typeface="Arial" pitchFamily="34" charset="0"/>
+              </a:rPr>
+              <a:t>13</a:t>
+            </a:r>
+            <a:r>
+              <a:rPr lang="en-US" sz="3400">
+                <a:latin typeface="Arial" pitchFamily="34" charset="0"/>
+                <a:cs typeface="Arial" pitchFamily="34" charset="0"/>
+              </a:rPr>
+              <a:t> </a:t>
+            </a:r>
+            <a:r>
+              <a:rPr lang="en-US" sz="3400" dirty="0">
+                <a:latin typeface="Arial" pitchFamily="34" charset="0"/>
+                <a:cs typeface="Arial" pitchFamily="34" charset="0"/>
+              </a:rPr>
+              <a:t>Adjusted OLS models compared current and neither status with planned participation, controlling for national network, EHR vendor network, and HIO participation, log CMS denominator, state, and survey year</a:t>
             </a:r>
           </a:p>
           <a:p>
@@ -4838,14 +5094,14 @@
               </a:spcBef>
             </a:pPr>
             <a:r>
-              <a:rPr lang="en-US" sz="2800" i="1" dirty="0">
+              <a:rPr lang="en-US" sz="2700" i="1" dirty="0">
                 <a:latin typeface="Arial" pitchFamily="34" charset="0"/>
                 <a:cs typeface="Arial" pitchFamily="34" charset="0"/>
               </a:rPr>
               <a:t>Note. </a:t>
             </a:r>
             <a:r>
-              <a:rPr lang="en-US" sz="2800" dirty="0">
+              <a:rPr lang="en-US" sz="2700" dirty="0">
                 <a:latin typeface="Arial" pitchFamily="34" charset="0"/>
                 <a:cs typeface="Arial" pitchFamily="34" charset="0"/>
               </a:rPr>
@@ -4980,8 +5236,8 @@
         </p:nvSpPr>
         <p:spPr bwMode="auto">
           <a:xfrm>
-            <a:off x="365760" y="6808803"/>
-            <a:ext cx="13350240" cy="5595673"/>
+            <a:off x="347567" y="6047861"/>
+            <a:ext cx="13578840" cy="6642113"/>
           </a:xfrm>
           <a:prstGeom prst="rect">
             <a:avLst/>
@@ -5010,7 +5266,28 @@
                 <a:latin typeface="Arial" pitchFamily="34" charset="0"/>
                 <a:cs typeface="Arial" pitchFamily="34" charset="0"/>
               </a:rPr>
-              <a:t>The Trusted Exchange Framework and Common Agreement (TEFCA) was established to support nationwide electronic health information exchange through a network-of-networks via Qualified Health Information Networks (QHINs). But evidence about hospital outcomes during its early implementation remains limited.</a:t>
+              <a:t>The Trusted Exchange Framework and Common Agreement (TEFCA) was established to support nationwide electronic health information exchange (HIE) through a network-of-networks of Qualified Health Information Networks (QHINs).</a:t>
+            </a:r>
+            <a:r>
+              <a:rPr lang="en-US" sz="3400" baseline="30000" dirty="0">
+                <a:latin typeface="Arial" pitchFamily="34" charset="0"/>
+                <a:cs typeface="Arial" pitchFamily="34" charset="0"/>
+              </a:rPr>
+              <a:t>1</a:t>
+            </a:r>
+            <a:r>
+              <a:rPr lang="en-US" sz="3400" dirty="0">
+                <a:latin typeface="Arial" pitchFamily="34" charset="0"/>
+                <a:cs typeface="Arial" pitchFamily="34" charset="0"/>
+              </a:rPr>
+              <a:t> Prior HIE research has reported operational and utilization benefits, but evidence for mortality remains limited and largely observational, particularly during TEFCA’s early implementation.</a:t>
+            </a:r>
+            <a:r>
+              <a:rPr lang="en-US" sz="3400" baseline="30000" dirty="0">
+                <a:latin typeface="Arial" pitchFamily="34" charset="0"/>
+                <a:cs typeface="Arial" pitchFamily="34" charset="0"/>
+              </a:rPr>
+              <a:t>2–11 </a:t>
             </a:r>
           </a:p>
           <a:p>
@@ -5024,14 +5301,14 @@
                 <a:latin typeface="Arial" pitchFamily="34" charset="0"/>
                 <a:cs typeface="Arial" pitchFamily="34" charset="0"/>
               </a:rPr>
-              <a:t>Objective: </a:t>
+              <a:t>Objective</a:t>
             </a:r>
             <a:r>
               <a:rPr lang="en-US" sz="3400" dirty="0">
                 <a:latin typeface="Arial" pitchFamily="34" charset="0"/>
                 <a:cs typeface="Arial" pitchFamily="34" charset="0"/>
               </a:rPr>
-              <a:t>Examine whether TEFCA participation, compared with planned participation, was associated with CMS Hybrid Hospital-Wide 30-Day Mortality among U.S. non-federal acute care hospitals. Heart failure and pneumonia mortality were evaluated as secondary outcomes.</a:t>
+              <a:t>: Examine whether current TEFCA participation, compared with planned participation, was associated with lower CMS Hybrid Hospital-Wide Mortality (Hybrid HWM) scores among U.S. non-federal acute care hospitals. Heart failure and pneumonia mortality were evaluated as secondary outcomes.</a:t>
             </a:r>
           </a:p>
         </p:txBody>
@@ -5047,7 +5324,7 @@
         <p:spPr bwMode="auto">
           <a:xfrm>
             <a:off x="33357312" y="15762301"/>
-            <a:ext cx="9509760" cy="11351094"/>
+            <a:ext cx="9509760" cy="6903723"/>
           </a:xfrm>
           <a:prstGeom prst="rect">
             <a:avLst/>
@@ -5076,21 +5353,7 @@
                 <a:latin typeface="Arial" pitchFamily="34" charset="0"/>
                 <a:cs typeface="Arial" pitchFamily="34" charset="0"/>
               </a:rPr>
-              <a:t>In this early hospital-level analysis, current TEFCA participation was not robustly associated with lower mortality than planned participation. The small positive Hybrid HWM estimate was sensitive to the standard-error method and was not reproduced for heart failure or pneumonia mortality; therefore, it should not be interpreted as evidence that TEFCA increased mortality.</a:t>
-            </a:r>
-          </a:p>
-          <a:p>
-            <a:pPr defTabSz="3458871">
-              <a:spcBef>
-                <a:spcPct val="50000"/>
-              </a:spcBef>
-            </a:pPr>
-            <a:r>
-              <a:rPr lang="en-US" sz="3400" dirty="0">
-                <a:latin typeface="Arial" pitchFamily="34" charset="0"/>
-                <a:cs typeface="Arial" pitchFamily="34" charset="0"/>
-              </a:rPr>
-              <a:t>Because planned hospitals could already participate in other exchange networks, this was not a comparison of TEFCA with no electronic exchange. EHR vendor-network participation was associated with lower Hybrid HWM, suggesting—but not proving—that more established exchange infrastructure or workflow integration may be relevant. Overall, reported participation alone may be an incomplete measure of effective information exchange. Longitudinal studies incorporating sustained TEFCA use, actual exchange activity, and later clinical outcomes are needed as implementation matures.</a:t>
+              <a:t>In this early hospital-level analysis, current TEFCA participation was not robustly associated with lower mortality than planned participation, and the small positive Hybrid HWM estimate was not reproduced across secondary outcomes. Because planned hospitals could already use other exchange networks, this was not a comparison with no electronic exchange. EHR vendor-network participation was associated with lower Hybrid HWM, but this observational finding does not establish causality. Longitudinal studies should evaluate sustained TEFCA use and actual exchange activity as implementation matures.</a:t>
             </a:r>
           </a:p>
         </p:txBody>
@@ -5171,7 +5434,7 @@
         </p:nvSpPr>
         <p:spPr bwMode="auto">
           <a:xfrm>
-            <a:off x="33203829" y="31978211"/>
+            <a:off x="33192718" y="31942617"/>
             <a:ext cx="9966962" cy="671248"/>
           </a:xfrm>
           <a:prstGeom prst="rect">
@@ -6015,7 +6278,7 @@
         <p:spPr>
           <a:xfrm>
             <a:off x="365839" y="22962128"/>
-            <a:ext cx="21652415" cy="584775"/>
+            <a:ext cx="21652415" cy="507831"/>
           </a:xfrm>
           <a:prstGeom prst="rect">
             <a:avLst/>
@@ -6029,11 +6292,11 @@
           <a:lstStyle/>
           <a:p>
             <a:r>
-              <a:rPr lang="en-US" sz="3200" i="1" dirty="0"/>
+              <a:rPr lang="en-US" sz="2700" i="1" dirty="0"/>
               <a:t>Note. </a:t>
             </a:r>
             <a:r>
-              <a:rPr lang="en-US" sz="3200" dirty="0"/>
+              <a:rPr lang="en-US" sz="2700" dirty="0"/>
               <a:t>Positive coefficients indicate higher mortality values; planned TEFCA participation was the reference category.</a:t>
             </a:r>
           </a:p>
@@ -6053,7 +6316,7 @@
         </p:nvSpPr>
         <p:spPr>
           <a:xfrm>
-            <a:off x="1257300" y="12469761"/>
+            <a:off x="1257300" y="12631666"/>
             <a:ext cx="11201400" cy="584775"/>
           </a:xfrm>
           <a:prstGeom prst="rect">
@@ -6113,11 +6376,11 @@
           <a:lstStyle/>
           <a:p>
             <a:r>
-              <a:rPr lang="en-US" sz="2800" b="1" dirty="0"/>
+              <a:rPr lang="en-US" sz="2700" b="1" dirty="0"/>
               <a:t>Figure 2. </a:t>
             </a:r>
             <a:r>
-              <a:rPr lang="en-US" sz="2800" dirty="0"/>
+              <a:rPr lang="en-US" sz="2700" dirty="0"/>
               <a:t>Adjusted associations with Hybrid HWM</a:t>
             </a:r>
           </a:p>
@@ -6498,11 +6761,11 @@
           <a:lstStyle/>
           <a:p>
             <a:r>
-              <a:rPr lang="en-US" sz="2800" b="1" dirty="0"/>
+              <a:rPr lang="en-US" sz="2700" b="1" dirty="0"/>
               <a:t>Table 1. </a:t>
             </a:r>
             <a:r>
-              <a:rPr lang="en-US" sz="2800" dirty="0"/>
+              <a:rPr lang="en-US" sz="2700" dirty="0"/>
               <a:t>TEFCA Participation Estimates Across Mortality Analyses</a:t>
             </a:r>
           </a:p>
@@ -6522,8 +6785,8 @@
         </p:nvSpPr>
         <p:spPr>
           <a:xfrm>
-            <a:off x="35309164" y="6262867"/>
-            <a:ext cx="7777363" cy="5847755"/>
+            <a:off x="36845849" y="6083718"/>
+            <a:ext cx="6240678" cy="7417415"/>
           </a:xfrm>
           <a:prstGeom prst="rect">
             <a:avLst/>
@@ -6593,8 +6856,8 @@
         </p:nvSpPr>
         <p:spPr>
           <a:xfrm>
-            <a:off x="26590752" y="12635211"/>
-            <a:ext cx="16568928" cy="1569660"/>
+            <a:off x="29632703" y="13469455"/>
+            <a:ext cx="13453824" cy="1338828"/>
           </a:xfrm>
           <a:prstGeom prst="rect">
             <a:avLst/>
@@ -6610,7 +6873,7 @@
           <a:lstStyle/>
           <a:p>
             <a:r>
-              <a:rPr lang="en-US" sz="3200" b="1" dirty="0"/>
+              <a:rPr lang="en-US" sz="2700" b="1" dirty="0"/>
               <a:t>Key finding: The analyses did not provide robust evidence that early current TEFCA participation was associated with lower hospital mortality than planned participation.</a:t>
             </a:r>
           </a:p>
@@ -6630,8 +6893,8 @@
         </p:nvSpPr>
         <p:spPr>
           <a:xfrm>
-            <a:off x="365760" y="31841182"/>
-            <a:ext cx="20711159" cy="1077218"/>
+            <a:off x="520017" y="31893924"/>
+            <a:ext cx="20711159" cy="923330"/>
           </a:xfrm>
           <a:prstGeom prst="rect">
             <a:avLst/>
@@ -6645,11 +6908,11 @@
           <a:lstStyle/>
           <a:p>
             <a:r>
-              <a:rPr lang="en-US" sz="3200" i="1" dirty="0"/>
+              <a:rPr lang="en-US" sz="2700" i="1" dirty="0"/>
               <a:t>Note. </a:t>
             </a:r>
             <a:r>
-              <a:rPr lang="en-US" sz="3200" dirty="0"/>
+              <a:rPr lang="en-US" sz="2700" dirty="0"/>
               <a:t>Points represent adjusted OLS coefficients; error bars represent 95% confidence intervals. Planned TEFCA participation was the reference category.</a:t>
             </a:r>
           </a:p>
@@ -6794,14 +7057,1121 @@
         </p:blipFill>
         <p:spPr>
           <a:xfrm>
-            <a:off x="14164449" y="6728346"/>
-            <a:ext cx="11889384" cy="4816957"/>
+            <a:off x="15354520" y="6117946"/>
+            <a:ext cx="11810558" cy="4785021"/>
           </a:xfrm>
           <a:prstGeom prst="rect">
             <a:avLst/>
           </a:prstGeom>
         </p:spPr>
       </p:pic>
+      <p:sp>
+        <p:nvSpPr>
+          <p:cNvPr id="1067" name="Text Box 45">
+            <a:extLst>
+              <a:ext uri="{FF2B5EF4-FFF2-40B4-BE49-F238E27FC236}">
+                <a16:creationId xmlns:a16="http://schemas.microsoft.com/office/drawing/2014/main" id="{90FF7E03-AF81-5A22-01FA-EF6B8005E07B}"/>
+              </a:ext>
+            </a:extLst>
+          </p:cNvPr>
+          <p:cNvSpPr txBox="1">
+            <a:spLocks noChangeArrowheads="1"/>
+          </p:cNvSpPr>
+          <p:nvPr/>
+        </p:nvSpPr>
+        <p:spPr bwMode="auto">
+          <a:xfrm>
+            <a:off x="33167213" y="22767459"/>
+            <a:ext cx="9939528" cy="808277"/>
+          </a:xfrm>
+          <a:prstGeom prst="rect">
+            <a:avLst/>
+          </a:prstGeom>
+          <a:solidFill>
+            <a:srgbClr val="AE6042"/>
+          </a:solidFill>
+          <a:ln w="12700">
+            <a:noFill/>
+            <a:miter lim="800000"/>
+            <a:headEnd/>
+            <a:tailEnd/>
+          </a:ln>
+        </p:spPr>
+        <p:txBody>
+          <a:bodyPr wrap="square" lIns="100875" tIns="50438" rIns="100875" bIns="50438" anchor="ctr">
+            <a:spAutoFit/>
+          </a:bodyPr>
+          <a:lstStyle>
+            <a:defPPr>
+              <a:defRPr lang="en-US"/>
+            </a:defPPr>
+            <a:lvl1pPr algn="ctr" defTabSz="5016500">
+              <a:spcBef>
+                <a:spcPct val="50000"/>
+              </a:spcBef>
+              <a:defRPr sz="3600">
+                <a:solidFill>
+                  <a:schemeClr val="bg1"/>
+                </a:solidFill>
+                <a:latin typeface="Calibri" pitchFamily="34" charset="0"/>
+                <a:cs typeface="Calibri" pitchFamily="34" charset="0"/>
+              </a:defRPr>
+            </a:lvl1pPr>
+          </a:lstStyle>
+          <a:p>
+            <a:r>
+              <a:rPr lang="en-US" sz="4500" dirty="0">
+                <a:latin typeface="Arial" pitchFamily="34" charset="0"/>
+                <a:cs typeface="Arial" pitchFamily="34" charset="0"/>
+              </a:rPr>
+              <a:t>SELECTED REFERENCES</a:t>
+            </a:r>
+          </a:p>
+        </p:txBody>
+      </p:sp>
+      <p:sp>
+        <p:nvSpPr>
+          <p:cNvPr id="1069" name="Rectangle 11">
+            <a:extLst>
+              <a:ext uri="{FF2B5EF4-FFF2-40B4-BE49-F238E27FC236}">
+                <a16:creationId xmlns:a16="http://schemas.microsoft.com/office/drawing/2014/main" id="{1119BEB3-184E-0733-EF53-DC6A69720D61}"/>
+              </a:ext>
+            </a:extLst>
+          </p:cNvPr>
+          <p:cNvSpPr>
+            <a:spLocks noChangeArrowheads="1"/>
+          </p:cNvSpPr>
+          <p:nvPr/>
+        </p:nvSpPr>
+        <p:spPr bwMode="auto">
+          <a:xfrm>
+            <a:off x="33147000" y="23317200"/>
+            <a:ext cx="9992466" cy="3970318"/>
+          </a:xfrm>
+          <a:prstGeom prst="rect">
+            <a:avLst/>
+          </a:prstGeom>
+          <a:noFill/>
+          <a:ln>
+            <a:noFill/>
+          </a:ln>
+          <a:effectLst/>
+          <a:extLst>
+            <a:ext uri="{909E8E84-426E-40DD-AFC4-6F175D3DCCD1}">
+              <a14:hiddenFill xmlns:a14="http://schemas.microsoft.com/office/drawing/2010/main">
+                <a:solidFill>
+                  <a:schemeClr val="accent1"/>
+                </a:solidFill>
+              </a14:hiddenFill>
+            </a:ext>
+            <a:ext uri="{91240B29-F687-4F45-9708-019B960494DF}">
+              <a14:hiddenLine xmlns:a14="http://schemas.microsoft.com/office/drawing/2010/main" w="9525">
+                <a:solidFill>
+                  <a:schemeClr val="tx1"/>
+                </a:solidFill>
+                <a:miter lim="800000"/>
+                <a:headEnd/>
+                <a:tailEnd/>
+              </a14:hiddenLine>
+            </a:ext>
+            <a:ext uri="{AF507438-7753-43E0-B8FC-AC1667EBCBE1}">
+              <a14:hiddenEffects xmlns:a14="http://schemas.microsoft.com/office/drawing/2010/main">
+                <a:effectLst>
+                  <a:outerShdw dist="35921" dir="2700000" algn="ctr" rotWithShape="0">
+                    <a:schemeClr val="bg2"/>
+                  </a:outerShdw>
+                </a:effectLst>
+              </a14:hiddenEffects>
+            </a:ext>
+          </a:extLst>
+        </p:spPr>
+        <p:txBody>
+          <a:bodyPr vert="horz" wrap="square" lIns="91440" tIns="45720" rIns="91440" bIns="45720" numCol="1" anchor="ctr" anchorCtr="0" compatLnSpc="1">
+            <a:prstTxWarp prst="textNoShape">
+              <a:avLst/>
+            </a:prstTxWarp>
+            <a:spAutoFit/>
+          </a:bodyPr>
+          <a:lstStyle/>
+          <a:p>
+            <a:pPr marL="342900" marR="0" lvl="0" indent="-342900" algn="l" defTabSz="914400" rtl="0" eaLnBrk="0" fontAlgn="base" latinLnBrk="0" hangingPunct="0">
+              <a:lnSpc>
+                <a:spcPct val="100000"/>
+              </a:lnSpc>
+              <a:spcBef>
+                <a:spcPct val="0"/>
+              </a:spcBef>
+              <a:spcAft>
+                <a:spcPct val="0"/>
+              </a:spcAft>
+              <a:buClrTx/>
+              <a:buSzTx/>
+              <a:buFont typeface="+mj-lt"/>
+              <a:buAutoNum type="arabicPeriod"/>
+              <a:tabLst/>
+            </a:pPr>
+            <a:endParaRPr kumimoji="0" lang="en-US" altLang="en-US" sz="1800" b="1" i="0" u="none" strike="noStrike" cap="none" normalizeH="0" baseline="0" dirty="0">
+              <a:ln>
+                <a:noFill/>
+              </a:ln>
+              <a:solidFill>
+                <a:schemeClr val="tx1"/>
+              </a:solidFill>
+              <a:effectLst/>
+              <a:latin typeface="Arial" panose="020B0604020202020204" pitchFamily="34" charset="0"/>
+            </a:endParaRPr>
+          </a:p>
+          <a:p>
+            <a:pPr marL="342900" marR="0" lvl="0" indent="-342900" algn="l" defTabSz="914400" rtl="0" eaLnBrk="0" fontAlgn="base" latinLnBrk="0" hangingPunct="0">
+              <a:lnSpc>
+                <a:spcPct val="100000"/>
+              </a:lnSpc>
+              <a:spcBef>
+                <a:spcPct val="0"/>
+              </a:spcBef>
+              <a:spcAft>
+                <a:spcPct val="0"/>
+              </a:spcAft>
+              <a:buClrTx/>
+              <a:buSzTx/>
+              <a:buFont typeface="+mj-lt"/>
+              <a:buAutoNum type="arabicPeriod"/>
+              <a:tabLst/>
+            </a:pPr>
+            <a:r>
+              <a:rPr kumimoji="0" lang="en-US" altLang="en-US" sz="1800" b="1" i="0" u="none" strike="noStrike" cap="none" normalizeH="0" baseline="0" dirty="0">
+                <a:ln>
+                  <a:noFill/>
+                </a:ln>
+                <a:solidFill>
+                  <a:schemeClr val="tx1"/>
+                </a:solidFill>
+                <a:effectLst/>
+                <a:latin typeface="Arial" panose="020B0604020202020204" pitchFamily="34" charset="0"/>
+              </a:rPr>
+              <a:t>Office of the National Coordinator for Health IT. </a:t>
+            </a:r>
+            <a:r>
+              <a:rPr kumimoji="0" lang="en-US" altLang="en-US" sz="1800" b="1" i="1" u="none" strike="noStrike" cap="none" normalizeH="0" baseline="0" dirty="0">
+                <a:ln>
+                  <a:noFill/>
+                </a:ln>
+                <a:solidFill>
+                  <a:schemeClr val="tx1"/>
+                </a:solidFill>
+                <a:effectLst/>
+                <a:latin typeface="Arial" panose="020B0604020202020204" pitchFamily="34" charset="0"/>
+              </a:rPr>
+              <a:t>TEFCA</a:t>
+            </a:r>
+            <a:r>
+              <a:rPr kumimoji="0" lang="en-US" altLang="en-US" sz="1800" b="1" i="0" u="none" strike="noStrike" cap="none" normalizeH="0" baseline="0" dirty="0">
+                <a:ln>
+                  <a:noFill/>
+                </a:ln>
+                <a:solidFill>
+                  <a:schemeClr val="tx1"/>
+                </a:solidFill>
+                <a:effectLst/>
+                <a:latin typeface="Arial" panose="020B0604020202020204" pitchFamily="34" charset="0"/>
+              </a:rPr>
+              <a:t>. 2026. </a:t>
+            </a:r>
+          </a:p>
+          <a:p>
+            <a:pPr marL="342900" marR="0" lvl="0" indent="-342900" algn="l" defTabSz="914400" rtl="0" eaLnBrk="0" fontAlgn="base" latinLnBrk="0" hangingPunct="0">
+              <a:lnSpc>
+                <a:spcPct val="100000"/>
+              </a:lnSpc>
+              <a:spcBef>
+                <a:spcPct val="0"/>
+              </a:spcBef>
+              <a:spcAft>
+                <a:spcPct val="0"/>
+              </a:spcAft>
+              <a:buClrTx/>
+              <a:buSzTx/>
+              <a:buFont typeface="+mj-lt"/>
+              <a:buAutoNum type="arabicPeriod"/>
+              <a:tabLst/>
+            </a:pPr>
+            <a:r>
+              <a:rPr kumimoji="0" lang="en-US" altLang="en-US" sz="1800" b="1" i="0" u="none" strike="noStrike" cap="none" normalizeH="0" baseline="0" dirty="0">
+                <a:ln>
+                  <a:noFill/>
+                </a:ln>
+                <a:solidFill>
+                  <a:schemeClr val="tx1"/>
+                </a:solidFill>
+                <a:effectLst/>
+                <a:latin typeface="Arial" panose="020B0604020202020204" pitchFamily="34" charset="0"/>
+              </a:rPr>
+              <a:t>Dupont S, et al. </a:t>
+            </a:r>
+            <a:r>
+              <a:rPr kumimoji="0" lang="en-US" altLang="en-US" sz="1800" b="1" i="1" u="none" strike="noStrike" cap="none" normalizeH="0" baseline="0" dirty="0">
+                <a:ln>
+                  <a:noFill/>
+                </a:ln>
+                <a:solidFill>
+                  <a:schemeClr val="tx1"/>
+                </a:solidFill>
+                <a:effectLst/>
+                <a:latin typeface="Arial" panose="020B0604020202020204" pitchFamily="34" charset="0"/>
+              </a:rPr>
+              <a:t>J Gen Intern Med.</a:t>
+            </a:r>
+            <a:r>
+              <a:rPr kumimoji="0" lang="en-US" altLang="en-US" sz="1800" b="1" i="0" u="none" strike="noStrike" cap="none" normalizeH="0" baseline="0" dirty="0">
+                <a:ln>
+                  <a:noFill/>
+                </a:ln>
+                <a:solidFill>
+                  <a:schemeClr val="tx1"/>
+                </a:solidFill>
+                <a:effectLst/>
+                <a:latin typeface="Arial" panose="020B0604020202020204" pitchFamily="34" charset="0"/>
+              </a:rPr>
+              <a:t> 2022;38:1046–1053. </a:t>
+            </a:r>
+          </a:p>
+          <a:p>
+            <a:pPr marL="342900" marR="0" lvl="0" indent="-342900" algn="l" defTabSz="914400" rtl="0" eaLnBrk="0" fontAlgn="base" latinLnBrk="0" hangingPunct="0">
+              <a:lnSpc>
+                <a:spcPct val="100000"/>
+              </a:lnSpc>
+              <a:spcBef>
+                <a:spcPct val="0"/>
+              </a:spcBef>
+              <a:spcAft>
+                <a:spcPct val="0"/>
+              </a:spcAft>
+              <a:buClrTx/>
+              <a:buSzTx/>
+              <a:buFont typeface="+mj-lt"/>
+              <a:buAutoNum type="arabicPeriod"/>
+              <a:tabLst/>
+            </a:pPr>
+            <a:r>
+              <a:rPr kumimoji="0" lang="en-US" altLang="en-US" sz="1800" b="1" i="0" u="none" strike="noStrike" cap="none" normalizeH="0" baseline="0" dirty="0">
+                <a:ln>
+                  <a:noFill/>
+                </a:ln>
+                <a:solidFill>
+                  <a:schemeClr val="tx1"/>
+                </a:solidFill>
+                <a:effectLst/>
+                <a:latin typeface="Arial" panose="020B0604020202020204" pitchFamily="34" charset="0"/>
+              </a:rPr>
+              <a:t>Everson J, et al. </a:t>
+            </a:r>
+            <a:r>
+              <a:rPr kumimoji="0" lang="en-US" altLang="en-US" sz="1800" b="1" i="1" u="none" strike="noStrike" cap="none" normalizeH="0" baseline="0" dirty="0">
+                <a:ln>
+                  <a:noFill/>
+                </a:ln>
+                <a:solidFill>
+                  <a:schemeClr val="tx1"/>
+                </a:solidFill>
+                <a:effectLst/>
+                <a:latin typeface="Arial" panose="020B0604020202020204" pitchFamily="34" charset="0"/>
+              </a:rPr>
+              <a:t>Health </a:t>
+            </a:r>
+            <a:r>
+              <a:rPr kumimoji="0" lang="en-US" altLang="en-US" sz="1800" b="1" i="1" u="none" strike="noStrike" cap="none" normalizeH="0" baseline="0" dirty="0" err="1">
+                <a:ln>
+                  <a:noFill/>
+                </a:ln>
+                <a:solidFill>
+                  <a:schemeClr val="tx1"/>
+                </a:solidFill>
+                <a:effectLst/>
+                <a:latin typeface="Arial" panose="020B0604020202020204" pitchFamily="34" charset="0"/>
+              </a:rPr>
+              <a:t>Aff</a:t>
+            </a:r>
+            <a:r>
+              <a:rPr kumimoji="0" lang="en-US" altLang="en-US" sz="1800" b="1" i="1" u="none" strike="noStrike" cap="none" normalizeH="0" baseline="0" dirty="0">
+                <a:ln>
+                  <a:noFill/>
+                </a:ln>
+                <a:solidFill>
+                  <a:schemeClr val="tx1"/>
+                </a:solidFill>
+                <a:effectLst/>
+                <a:latin typeface="Arial" panose="020B0604020202020204" pitchFamily="34" charset="0"/>
+              </a:rPr>
+              <a:t> Sch.</a:t>
+            </a:r>
+            <a:r>
+              <a:rPr kumimoji="0" lang="en-US" altLang="en-US" sz="1800" b="1" i="0" u="none" strike="noStrike" cap="none" normalizeH="0" baseline="0" dirty="0">
+                <a:ln>
+                  <a:noFill/>
+                </a:ln>
+                <a:solidFill>
+                  <a:schemeClr val="tx1"/>
+                </a:solidFill>
+                <a:effectLst/>
+                <a:latin typeface="Arial" panose="020B0604020202020204" pitchFamily="34" charset="0"/>
+              </a:rPr>
+              <a:t> 2024;2:qxae098. </a:t>
+            </a:r>
+          </a:p>
+          <a:p>
+            <a:pPr marL="342900" marR="0" lvl="0" indent="-342900" algn="l" defTabSz="914400" rtl="0" eaLnBrk="0" fontAlgn="base" latinLnBrk="0" hangingPunct="0">
+              <a:lnSpc>
+                <a:spcPct val="100000"/>
+              </a:lnSpc>
+              <a:spcBef>
+                <a:spcPct val="0"/>
+              </a:spcBef>
+              <a:spcAft>
+                <a:spcPct val="0"/>
+              </a:spcAft>
+              <a:buClrTx/>
+              <a:buSzTx/>
+              <a:buFont typeface="+mj-lt"/>
+              <a:buAutoNum type="arabicPeriod"/>
+              <a:tabLst/>
+            </a:pPr>
+            <a:r>
+              <a:rPr kumimoji="0" lang="en-US" altLang="en-US" sz="1800" b="1" i="0" u="none" strike="noStrike" cap="none" normalizeH="0" baseline="0" dirty="0" err="1">
+                <a:ln>
+                  <a:noFill/>
+                </a:ln>
+                <a:solidFill>
+                  <a:schemeClr val="tx1"/>
+                </a:solidFill>
+                <a:effectLst/>
+                <a:latin typeface="Arial" panose="020B0604020202020204" pitchFamily="34" charset="0"/>
+              </a:rPr>
+              <a:t>Frisse</a:t>
+            </a:r>
+            <a:r>
+              <a:rPr kumimoji="0" lang="en-US" altLang="en-US" sz="1800" b="1" i="0" u="none" strike="noStrike" cap="none" normalizeH="0" baseline="0" dirty="0">
+                <a:ln>
+                  <a:noFill/>
+                </a:ln>
+                <a:solidFill>
+                  <a:schemeClr val="tx1"/>
+                </a:solidFill>
+                <a:effectLst/>
+                <a:latin typeface="Arial" panose="020B0604020202020204" pitchFamily="34" charset="0"/>
+              </a:rPr>
+              <a:t> ME, et al. </a:t>
+            </a:r>
+            <a:r>
+              <a:rPr kumimoji="0" lang="en-US" altLang="en-US" sz="1800" b="1" i="1" u="none" strike="noStrike" cap="none" normalizeH="0" baseline="0" dirty="0">
+                <a:ln>
+                  <a:noFill/>
+                </a:ln>
+                <a:solidFill>
+                  <a:schemeClr val="tx1"/>
+                </a:solidFill>
+                <a:effectLst/>
+                <a:latin typeface="Arial" panose="020B0604020202020204" pitchFamily="34" charset="0"/>
+              </a:rPr>
+              <a:t>J Am Med Inform Assoc.</a:t>
+            </a:r>
+            <a:r>
+              <a:rPr kumimoji="0" lang="en-US" altLang="en-US" sz="1800" b="1" i="0" u="none" strike="noStrike" cap="none" normalizeH="0" baseline="0" dirty="0">
+                <a:ln>
+                  <a:noFill/>
+                </a:ln>
+                <a:solidFill>
+                  <a:schemeClr val="tx1"/>
+                </a:solidFill>
+                <a:effectLst/>
+                <a:latin typeface="Arial" panose="020B0604020202020204" pitchFamily="34" charset="0"/>
+              </a:rPr>
+              <a:t> 2012;19:328–333. </a:t>
+            </a:r>
+          </a:p>
+          <a:p>
+            <a:pPr marL="342900" marR="0" lvl="0" indent="-342900" algn="l" defTabSz="914400" rtl="0" eaLnBrk="0" fontAlgn="base" latinLnBrk="0" hangingPunct="0">
+              <a:lnSpc>
+                <a:spcPct val="100000"/>
+              </a:lnSpc>
+              <a:spcBef>
+                <a:spcPct val="0"/>
+              </a:spcBef>
+              <a:spcAft>
+                <a:spcPct val="0"/>
+              </a:spcAft>
+              <a:buClrTx/>
+              <a:buSzTx/>
+              <a:buFont typeface="+mj-lt"/>
+              <a:buAutoNum type="arabicPeriod"/>
+              <a:tabLst/>
+            </a:pPr>
+            <a:r>
+              <a:rPr kumimoji="0" lang="en-US" altLang="en-US" sz="1800" b="1" i="0" u="none" strike="noStrike" cap="none" normalizeH="0" baseline="0" dirty="0">
+                <a:ln>
+                  <a:noFill/>
+                </a:ln>
+                <a:solidFill>
+                  <a:schemeClr val="tx1"/>
+                </a:solidFill>
+                <a:effectLst/>
+                <a:latin typeface="Arial" panose="020B0604020202020204" pitchFamily="34" charset="0"/>
+              </a:rPr>
+              <a:t>Hersh WR, et al. </a:t>
+            </a:r>
+            <a:r>
+              <a:rPr kumimoji="0" lang="en-US" altLang="en-US" sz="1800" b="1" i="1" u="none" strike="noStrike" cap="none" normalizeH="0" baseline="0" dirty="0">
+                <a:ln>
+                  <a:noFill/>
+                </a:ln>
+                <a:solidFill>
+                  <a:schemeClr val="tx1"/>
+                </a:solidFill>
+                <a:effectLst/>
+                <a:latin typeface="Arial" panose="020B0604020202020204" pitchFamily="34" charset="0"/>
+              </a:rPr>
+              <a:t>JMIR Med Inform.</a:t>
+            </a:r>
+            <a:r>
+              <a:rPr kumimoji="0" lang="en-US" altLang="en-US" sz="1800" b="1" i="0" u="none" strike="noStrike" cap="none" normalizeH="0" baseline="0" dirty="0">
+                <a:ln>
+                  <a:noFill/>
+                </a:ln>
+                <a:solidFill>
+                  <a:schemeClr val="tx1"/>
+                </a:solidFill>
+                <a:effectLst/>
+                <a:latin typeface="Arial" panose="020B0604020202020204" pitchFamily="34" charset="0"/>
+              </a:rPr>
+              <a:t> 2015;3:e39. </a:t>
+            </a:r>
+          </a:p>
+          <a:p>
+            <a:pPr marL="342900" marR="0" lvl="0" indent="-342900" algn="l" defTabSz="914400" rtl="0" eaLnBrk="0" fontAlgn="base" latinLnBrk="0" hangingPunct="0">
+              <a:lnSpc>
+                <a:spcPct val="100000"/>
+              </a:lnSpc>
+              <a:spcBef>
+                <a:spcPct val="0"/>
+              </a:spcBef>
+              <a:spcAft>
+                <a:spcPct val="0"/>
+              </a:spcAft>
+              <a:buClrTx/>
+              <a:buSzTx/>
+              <a:buFont typeface="+mj-lt"/>
+              <a:buAutoNum type="arabicPeriod"/>
+              <a:tabLst/>
+            </a:pPr>
+            <a:r>
+              <a:rPr kumimoji="0" lang="en-US" altLang="en-US" sz="1800" b="1" i="0" u="none" strike="noStrike" cap="none" normalizeH="0" baseline="0" dirty="0">
+                <a:ln>
+                  <a:noFill/>
+                </a:ln>
+                <a:solidFill>
+                  <a:schemeClr val="tx1"/>
+                </a:solidFill>
+                <a:effectLst/>
+                <a:latin typeface="Arial" panose="020B0604020202020204" pitchFamily="34" charset="0"/>
+              </a:rPr>
+              <a:t>Hincapie A, </a:t>
+            </a:r>
+            <a:r>
+              <a:rPr kumimoji="0" lang="en-US" altLang="en-US" sz="1800" b="1" i="0" u="none" strike="noStrike" cap="none" normalizeH="0" baseline="0" dirty="0" err="1">
+                <a:ln>
+                  <a:noFill/>
+                </a:ln>
+                <a:solidFill>
+                  <a:schemeClr val="tx1"/>
+                </a:solidFill>
+                <a:effectLst/>
+                <a:latin typeface="Arial" panose="020B0604020202020204" pitchFamily="34" charset="0"/>
+              </a:rPr>
+              <a:t>Warholak</a:t>
+            </a:r>
+            <a:r>
+              <a:rPr kumimoji="0" lang="en-US" altLang="en-US" sz="1800" b="1" i="0" u="none" strike="noStrike" cap="none" normalizeH="0" baseline="0" dirty="0">
+                <a:ln>
+                  <a:noFill/>
+                </a:ln>
+                <a:solidFill>
+                  <a:schemeClr val="tx1"/>
+                </a:solidFill>
+                <a:effectLst/>
+                <a:latin typeface="Arial" panose="020B0604020202020204" pitchFamily="34" charset="0"/>
+              </a:rPr>
+              <a:t> T. </a:t>
+            </a:r>
+            <a:r>
+              <a:rPr kumimoji="0" lang="en-US" altLang="en-US" sz="1800" b="1" i="1" u="none" strike="noStrike" cap="none" normalizeH="0" baseline="0" dirty="0">
+                <a:ln>
+                  <a:noFill/>
+                </a:ln>
+                <a:solidFill>
+                  <a:schemeClr val="tx1"/>
+                </a:solidFill>
+                <a:effectLst/>
+                <a:latin typeface="Arial" panose="020B0604020202020204" pitchFamily="34" charset="0"/>
+              </a:rPr>
+              <a:t>Appl Clin Inform.</a:t>
+            </a:r>
+            <a:r>
+              <a:rPr kumimoji="0" lang="en-US" altLang="en-US" sz="1800" b="1" i="0" u="none" strike="noStrike" cap="none" normalizeH="0" baseline="0" dirty="0">
+                <a:ln>
+                  <a:noFill/>
+                </a:ln>
+                <a:solidFill>
+                  <a:schemeClr val="tx1"/>
+                </a:solidFill>
+                <a:effectLst/>
+                <a:latin typeface="Arial" panose="020B0604020202020204" pitchFamily="34" charset="0"/>
+              </a:rPr>
+              <a:t> 2011;2:499–507. </a:t>
+            </a:r>
+          </a:p>
+          <a:p>
+            <a:pPr marL="342900" marR="0" lvl="0" indent="-342900" algn="l" defTabSz="914400" rtl="0" eaLnBrk="0" fontAlgn="base" latinLnBrk="0" hangingPunct="0">
+              <a:lnSpc>
+                <a:spcPct val="100000"/>
+              </a:lnSpc>
+              <a:spcBef>
+                <a:spcPct val="0"/>
+              </a:spcBef>
+              <a:spcAft>
+                <a:spcPct val="0"/>
+              </a:spcAft>
+              <a:buClrTx/>
+              <a:buSzTx/>
+              <a:buFont typeface="+mj-lt"/>
+              <a:buAutoNum type="arabicPeriod"/>
+              <a:tabLst/>
+            </a:pPr>
+            <a:r>
+              <a:rPr kumimoji="0" lang="en-US" altLang="en-US" sz="1800" b="1" i="0" u="none" strike="noStrike" cap="none" normalizeH="0" baseline="0" dirty="0" err="1">
+                <a:ln>
+                  <a:noFill/>
+                </a:ln>
+                <a:solidFill>
+                  <a:schemeClr val="tx1"/>
+                </a:solidFill>
+                <a:effectLst/>
+                <a:latin typeface="Arial" panose="020B0604020202020204" pitchFamily="34" charset="0"/>
+              </a:rPr>
+              <a:t>Janakiraman</a:t>
+            </a:r>
+            <a:r>
+              <a:rPr kumimoji="0" lang="en-US" altLang="en-US" sz="1800" b="1" i="0" u="none" strike="noStrike" cap="none" normalizeH="0" baseline="0" dirty="0">
+                <a:ln>
+                  <a:noFill/>
+                </a:ln>
+                <a:solidFill>
+                  <a:schemeClr val="tx1"/>
+                </a:solidFill>
+                <a:effectLst/>
+                <a:latin typeface="Arial" panose="020B0604020202020204" pitchFamily="34" charset="0"/>
+              </a:rPr>
+              <a:t> R, et al. </a:t>
+            </a:r>
+            <a:r>
+              <a:rPr kumimoji="0" lang="en-US" altLang="en-US" sz="1800" b="1" i="1" u="none" strike="noStrike" cap="none" normalizeH="0" baseline="0" dirty="0">
+                <a:ln>
+                  <a:noFill/>
+                </a:ln>
+                <a:solidFill>
+                  <a:schemeClr val="tx1"/>
+                </a:solidFill>
+                <a:effectLst/>
+                <a:latin typeface="Arial" panose="020B0604020202020204" pitchFamily="34" charset="0"/>
+              </a:rPr>
+              <a:t>Manage Sci.</a:t>
+            </a:r>
+            <a:r>
+              <a:rPr kumimoji="0" lang="en-US" altLang="en-US" sz="1800" b="1" i="0" u="none" strike="noStrike" cap="none" normalizeH="0" baseline="0" dirty="0">
+                <a:ln>
+                  <a:noFill/>
+                </a:ln>
+                <a:solidFill>
+                  <a:schemeClr val="tx1"/>
+                </a:solidFill>
+                <a:effectLst/>
+                <a:latin typeface="Arial" panose="020B0604020202020204" pitchFamily="34" charset="0"/>
+              </a:rPr>
+              <a:t> 2022;69:791–811. </a:t>
+            </a:r>
+          </a:p>
+          <a:p>
+            <a:pPr marL="342900" marR="0" lvl="0" indent="-342900" algn="l" defTabSz="914400" rtl="0" eaLnBrk="0" fontAlgn="base" latinLnBrk="0" hangingPunct="0">
+              <a:lnSpc>
+                <a:spcPct val="100000"/>
+              </a:lnSpc>
+              <a:spcBef>
+                <a:spcPct val="0"/>
+              </a:spcBef>
+              <a:spcAft>
+                <a:spcPct val="0"/>
+              </a:spcAft>
+              <a:buClrTx/>
+              <a:buSzTx/>
+              <a:buFont typeface="+mj-lt"/>
+              <a:buAutoNum type="arabicPeriod"/>
+              <a:tabLst/>
+            </a:pPr>
+            <a:r>
+              <a:rPr kumimoji="0" lang="en-US" altLang="en-US" sz="1800" b="1" i="0" u="none" strike="noStrike" cap="none" normalizeH="0" baseline="0" dirty="0">
+                <a:ln>
+                  <a:noFill/>
+                </a:ln>
+                <a:solidFill>
+                  <a:schemeClr val="tx1"/>
+                </a:solidFill>
+                <a:effectLst/>
+                <a:latin typeface="Arial" panose="020B0604020202020204" pitchFamily="34" charset="0"/>
+              </a:rPr>
+              <a:t>Kim HJ, Choi S. </a:t>
+            </a:r>
+            <a:r>
+              <a:rPr kumimoji="0" lang="en-US" altLang="en-US" sz="1800" b="1" i="1" u="none" strike="noStrike" cap="none" normalizeH="0" baseline="0" dirty="0">
+                <a:ln>
+                  <a:noFill/>
+                </a:ln>
+                <a:solidFill>
+                  <a:schemeClr val="tx1"/>
+                </a:solidFill>
+                <a:effectLst/>
+                <a:latin typeface="Arial" panose="020B0604020202020204" pitchFamily="34" charset="0"/>
+              </a:rPr>
+              <a:t>J Korean </a:t>
+            </a:r>
+            <a:r>
+              <a:rPr kumimoji="0" lang="en-US" altLang="en-US" sz="1800" b="1" i="1" u="none" strike="noStrike" cap="none" normalizeH="0" baseline="0" dirty="0" err="1">
+                <a:ln>
+                  <a:noFill/>
+                </a:ln>
+                <a:solidFill>
+                  <a:schemeClr val="tx1"/>
+                </a:solidFill>
+                <a:effectLst/>
+                <a:latin typeface="Arial" panose="020B0604020202020204" pitchFamily="34" charset="0"/>
+              </a:rPr>
+              <a:t>Acad</a:t>
+            </a:r>
+            <a:r>
+              <a:rPr kumimoji="0" lang="en-US" altLang="en-US" sz="1800" b="1" i="1" u="none" strike="noStrike" cap="none" normalizeH="0" baseline="0" dirty="0">
+                <a:ln>
+                  <a:noFill/>
+                </a:ln>
+                <a:solidFill>
+                  <a:schemeClr val="tx1"/>
+                </a:solidFill>
+                <a:effectLst/>
+                <a:latin typeface="Arial" panose="020B0604020202020204" pitchFamily="34" charset="0"/>
+              </a:rPr>
+              <a:t> </a:t>
+            </a:r>
+            <a:r>
+              <a:rPr kumimoji="0" lang="en-US" altLang="en-US" sz="1800" b="1" i="1" u="none" strike="noStrike" cap="none" normalizeH="0" baseline="0" dirty="0" err="1">
+                <a:ln>
+                  <a:noFill/>
+                </a:ln>
+                <a:solidFill>
+                  <a:schemeClr val="tx1"/>
+                </a:solidFill>
+                <a:effectLst/>
+                <a:latin typeface="Arial" panose="020B0604020202020204" pitchFamily="34" charset="0"/>
+              </a:rPr>
+              <a:t>Fundam</a:t>
+            </a:r>
+            <a:r>
+              <a:rPr kumimoji="0" lang="en-US" altLang="en-US" sz="1800" b="1" i="1" u="none" strike="noStrike" cap="none" normalizeH="0" baseline="0" dirty="0">
+                <a:ln>
+                  <a:noFill/>
+                </a:ln>
+                <a:solidFill>
+                  <a:schemeClr val="tx1"/>
+                </a:solidFill>
+                <a:effectLst/>
+                <a:latin typeface="Arial" panose="020B0604020202020204" pitchFamily="34" charset="0"/>
+              </a:rPr>
+              <a:t> </a:t>
+            </a:r>
+            <a:r>
+              <a:rPr kumimoji="0" lang="en-US" altLang="en-US" sz="1800" b="1" i="1" u="none" strike="noStrike" cap="none" normalizeH="0" baseline="0" dirty="0" err="1">
+                <a:ln>
+                  <a:noFill/>
+                </a:ln>
+                <a:solidFill>
+                  <a:schemeClr val="tx1"/>
+                </a:solidFill>
+                <a:effectLst/>
+                <a:latin typeface="Arial" panose="020B0604020202020204" pitchFamily="34" charset="0"/>
+              </a:rPr>
+              <a:t>Nurs</a:t>
+            </a:r>
+            <a:r>
+              <a:rPr kumimoji="0" lang="en-US" altLang="en-US" sz="1800" b="1" i="1" u="none" strike="noStrike" cap="none" normalizeH="0" baseline="0" dirty="0">
+                <a:ln>
+                  <a:noFill/>
+                </a:ln>
+                <a:solidFill>
+                  <a:schemeClr val="tx1"/>
+                </a:solidFill>
+                <a:effectLst/>
+                <a:latin typeface="Arial" panose="020B0604020202020204" pitchFamily="34" charset="0"/>
+              </a:rPr>
+              <a:t>.</a:t>
+            </a:r>
+            <a:r>
+              <a:rPr kumimoji="0" lang="en-US" altLang="en-US" sz="1800" b="1" i="0" u="none" strike="noStrike" cap="none" normalizeH="0" baseline="0" dirty="0">
+                <a:ln>
+                  <a:noFill/>
+                </a:ln>
+                <a:solidFill>
+                  <a:schemeClr val="tx1"/>
+                </a:solidFill>
+                <a:effectLst/>
+                <a:latin typeface="Arial" panose="020B0604020202020204" pitchFamily="34" charset="0"/>
+              </a:rPr>
+              <a:t> 2025;32:243–252. </a:t>
+            </a:r>
+          </a:p>
+          <a:p>
+            <a:pPr marL="342900" marR="0" lvl="0" indent="-342900" algn="l" defTabSz="914400" rtl="0" eaLnBrk="0" fontAlgn="base" latinLnBrk="0" hangingPunct="0">
+              <a:lnSpc>
+                <a:spcPct val="100000"/>
+              </a:lnSpc>
+              <a:spcBef>
+                <a:spcPct val="0"/>
+              </a:spcBef>
+              <a:spcAft>
+                <a:spcPct val="0"/>
+              </a:spcAft>
+              <a:buClrTx/>
+              <a:buSzTx/>
+              <a:buFont typeface="+mj-lt"/>
+              <a:buAutoNum type="arabicPeriod"/>
+              <a:tabLst/>
+            </a:pPr>
+            <a:r>
+              <a:rPr kumimoji="0" lang="en-US" altLang="en-US" sz="1800" b="1" i="0" u="none" strike="noStrike" cap="none" normalizeH="0" baseline="0" dirty="0" err="1">
+                <a:ln>
+                  <a:noFill/>
+                </a:ln>
+                <a:solidFill>
+                  <a:schemeClr val="tx1"/>
+                </a:solidFill>
+                <a:effectLst/>
+                <a:latin typeface="Arial" panose="020B0604020202020204" pitchFamily="34" charset="0"/>
+              </a:rPr>
+              <a:t>Menachemi</a:t>
+            </a:r>
+            <a:r>
+              <a:rPr kumimoji="0" lang="en-US" altLang="en-US" sz="1800" b="1" i="0" u="none" strike="noStrike" cap="none" normalizeH="0" baseline="0" dirty="0">
+                <a:ln>
+                  <a:noFill/>
+                </a:ln>
+                <a:solidFill>
+                  <a:schemeClr val="tx1"/>
+                </a:solidFill>
+                <a:effectLst/>
+                <a:latin typeface="Arial" panose="020B0604020202020204" pitchFamily="34" charset="0"/>
+              </a:rPr>
+              <a:t> N, et al. </a:t>
+            </a:r>
+            <a:r>
+              <a:rPr kumimoji="0" lang="en-US" altLang="en-US" sz="1800" b="1" i="1" u="none" strike="noStrike" cap="none" normalizeH="0" baseline="0" dirty="0">
+                <a:ln>
+                  <a:noFill/>
+                </a:ln>
+                <a:solidFill>
+                  <a:schemeClr val="tx1"/>
+                </a:solidFill>
+                <a:effectLst/>
+                <a:latin typeface="Arial" panose="020B0604020202020204" pitchFamily="34" charset="0"/>
+              </a:rPr>
+              <a:t>J Am Med Inform Assoc.</a:t>
+            </a:r>
+            <a:r>
+              <a:rPr kumimoji="0" lang="en-US" altLang="en-US" sz="1800" b="1" i="0" u="none" strike="noStrike" cap="none" normalizeH="0" baseline="0" dirty="0">
+                <a:ln>
+                  <a:noFill/>
+                </a:ln>
+                <a:solidFill>
+                  <a:schemeClr val="tx1"/>
+                </a:solidFill>
+                <a:effectLst/>
+                <a:latin typeface="Arial" panose="020B0604020202020204" pitchFamily="34" charset="0"/>
+              </a:rPr>
+              <a:t> 2018;25:1259–1265. </a:t>
+            </a:r>
+          </a:p>
+          <a:p>
+            <a:pPr marL="342900" marR="0" lvl="0" indent="-342900" algn="l" defTabSz="914400" rtl="0" eaLnBrk="0" fontAlgn="base" latinLnBrk="0" hangingPunct="0">
+              <a:lnSpc>
+                <a:spcPct val="100000"/>
+              </a:lnSpc>
+              <a:spcBef>
+                <a:spcPct val="0"/>
+              </a:spcBef>
+              <a:spcAft>
+                <a:spcPct val="0"/>
+              </a:spcAft>
+              <a:buClrTx/>
+              <a:buSzTx/>
+              <a:buFont typeface="+mj-lt"/>
+              <a:buAutoNum type="arabicPeriod"/>
+              <a:tabLst/>
+            </a:pPr>
+            <a:r>
+              <a:rPr kumimoji="0" lang="en-US" altLang="en-US" sz="1800" b="1" i="0" u="none" strike="noStrike" cap="none" normalizeH="0" baseline="0" dirty="0" err="1">
+                <a:ln>
+                  <a:noFill/>
+                </a:ln>
+                <a:solidFill>
+                  <a:schemeClr val="tx1"/>
+                </a:solidFill>
+                <a:effectLst/>
+                <a:latin typeface="Arial" panose="020B0604020202020204" pitchFamily="34" charset="0"/>
+              </a:rPr>
+              <a:t>Sadoughi</a:t>
+            </a:r>
+            <a:r>
+              <a:rPr kumimoji="0" lang="en-US" altLang="en-US" sz="1800" b="1" i="0" u="none" strike="noStrike" cap="none" normalizeH="0" baseline="0" dirty="0">
+                <a:ln>
+                  <a:noFill/>
+                </a:ln>
+                <a:solidFill>
+                  <a:schemeClr val="tx1"/>
+                </a:solidFill>
+                <a:effectLst/>
+                <a:latin typeface="Arial" panose="020B0604020202020204" pitchFamily="34" charset="0"/>
+              </a:rPr>
+              <a:t> F, et al. </a:t>
+            </a:r>
+            <a:r>
+              <a:rPr kumimoji="0" lang="en-US" altLang="en-US" sz="1800" b="1" i="1" u="none" strike="noStrike" cap="none" normalizeH="0" baseline="0" dirty="0" err="1">
+                <a:ln>
+                  <a:noFill/>
+                </a:ln>
+                <a:solidFill>
+                  <a:schemeClr val="tx1"/>
+                </a:solidFill>
+                <a:effectLst/>
+                <a:latin typeface="Arial" panose="020B0604020202020204" pitchFamily="34" charset="0"/>
+              </a:rPr>
+              <a:t>Comput</a:t>
+            </a:r>
+            <a:r>
+              <a:rPr kumimoji="0" lang="en-US" altLang="en-US" sz="1800" b="1" i="1" u="none" strike="noStrike" cap="none" normalizeH="0" baseline="0" dirty="0">
+                <a:ln>
+                  <a:noFill/>
+                </a:ln>
+                <a:solidFill>
+                  <a:schemeClr val="tx1"/>
+                </a:solidFill>
+                <a:effectLst/>
+                <a:latin typeface="Arial" panose="020B0604020202020204" pitchFamily="34" charset="0"/>
+              </a:rPr>
+              <a:t> Methods Programs Biomed.</a:t>
+            </a:r>
+            <a:r>
+              <a:rPr kumimoji="0" lang="en-US" altLang="en-US" sz="1800" b="1" i="0" u="none" strike="noStrike" cap="none" normalizeH="0" baseline="0" dirty="0">
+                <a:ln>
+                  <a:noFill/>
+                </a:ln>
+                <a:solidFill>
+                  <a:schemeClr val="tx1"/>
+                </a:solidFill>
+                <a:effectLst/>
+                <a:latin typeface="Arial" panose="020B0604020202020204" pitchFamily="34" charset="0"/>
+              </a:rPr>
+              <a:t> 2018;161:209–232. </a:t>
+            </a:r>
+          </a:p>
+          <a:p>
+            <a:pPr marL="342900" marR="0" lvl="0" indent="-342900" algn="l" defTabSz="914400" rtl="0" eaLnBrk="0" fontAlgn="base" latinLnBrk="0" hangingPunct="0">
+              <a:lnSpc>
+                <a:spcPct val="100000"/>
+              </a:lnSpc>
+              <a:spcBef>
+                <a:spcPct val="0"/>
+              </a:spcBef>
+              <a:spcAft>
+                <a:spcPct val="0"/>
+              </a:spcAft>
+              <a:buClrTx/>
+              <a:buSzTx/>
+              <a:buFont typeface="+mj-lt"/>
+              <a:buAutoNum type="arabicPeriod"/>
+              <a:tabLst/>
+            </a:pPr>
+            <a:r>
+              <a:rPr kumimoji="0" lang="en-US" altLang="en-US" sz="1800" b="1" i="0" u="none" strike="noStrike" cap="none" normalizeH="0" baseline="0" dirty="0" err="1">
+                <a:ln>
+                  <a:noFill/>
+                </a:ln>
+                <a:solidFill>
+                  <a:schemeClr val="tx1"/>
+                </a:solidFill>
+                <a:effectLst/>
+                <a:latin typeface="Arial" panose="020B0604020202020204" pitchFamily="34" charset="0"/>
+              </a:rPr>
+              <a:t>Turbow</a:t>
+            </a:r>
+            <a:r>
+              <a:rPr kumimoji="0" lang="en-US" altLang="en-US" sz="1800" b="1" i="0" u="none" strike="noStrike" cap="none" normalizeH="0" baseline="0" dirty="0">
+                <a:ln>
+                  <a:noFill/>
+                </a:ln>
+                <a:solidFill>
+                  <a:schemeClr val="tx1"/>
+                </a:solidFill>
+                <a:effectLst/>
+                <a:latin typeface="Arial" panose="020B0604020202020204" pitchFamily="34" charset="0"/>
+              </a:rPr>
+              <a:t> S, et al. </a:t>
+            </a:r>
+            <a:r>
+              <a:rPr kumimoji="0" lang="en-US" altLang="en-US" sz="1800" b="1" i="1" u="none" strike="noStrike" cap="none" normalizeH="0" baseline="0" dirty="0">
+                <a:ln>
+                  <a:noFill/>
+                </a:ln>
+                <a:solidFill>
+                  <a:schemeClr val="tx1"/>
+                </a:solidFill>
+                <a:effectLst/>
+                <a:latin typeface="Arial" panose="020B0604020202020204" pitchFamily="34" charset="0"/>
+              </a:rPr>
+              <a:t>JMIR Aging.</a:t>
+            </a:r>
+            <a:r>
+              <a:rPr kumimoji="0" lang="en-US" altLang="en-US" sz="1800" b="1" i="0" u="none" strike="noStrike" cap="none" normalizeH="0" baseline="0" dirty="0">
+                <a:ln>
+                  <a:noFill/>
+                </a:ln>
+                <a:solidFill>
+                  <a:schemeClr val="tx1"/>
+                </a:solidFill>
+                <a:effectLst/>
+                <a:latin typeface="Arial" panose="020B0604020202020204" pitchFamily="34" charset="0"/>
+              </a:rPr>
+              <a:t> 2023;6:e41936. </a:t>
+            </a:r>
+          </a:p>
+          <a:p>
+            <a:pPr marL="342900" marR="0" lvl="0" indent="-342900" algn="l" defTabSz="914400" rtl="0" eaLnBrk="0" fontAlgn="base" latinLnBrk="0" hangingPunct="0">
+              <a:lnSpc>
+                <a:spcPct val="100000"/>
+              </a:lnSpc>
+              <a:spcBef>
+                <a:spcPct val="0"/>
+              </a:spcBef>
+              <a:spcAft>
+                <a:spcPct val="0"/>
+              </a:spcAft>
+              <a:buClrTx/>
+              <a:buSzTx/>
+              <a:buFont typeface="+mj-lt"/>
+              <a:buAutoNum type="arabicPeriod"/>
+              <a:tabLst/>
+            </a:pPr>
+            <a:r>
+              <a:rPr kumimoji="0" lang="en-US" altLang="en-US" sz="1800" b="1" i="0" u="none" strike="noStrike" cap="none" normalizeH="0" baseline="0" dirty="0">
+                <a:ln>
+                  <a:noFill/>
+                </a:ln>
+                <a:solidFill>
+                  <a:schemeClr val="tx1"/>
+                </a:solidFill>
+                <a:effectLst/>
+                <a:latin typeface="Arial" panose="020B0604020202020204" pitchFamily="34" charset="0"/>
+              </a:rPr>
+              <a:t>ONC. </a:t>
+            </a:r>
+            <a:r>
+              <a:rPr kumimoji="0" lang="en-US" altLang="en-US" sz="1800" b="1" i="1" u="none" strike="noStrike" cap="none" normalizeH="0" baseline="0" dirty="0">
+                <a:ln>
+                  <a:noFill/>
+                </a:ln>
+                <a:solidFill>
+                  <a:schemeClr val="tx1"/>
+                </a:solidFill>
+                <a:effectLst/>
+                <a:latin typeface="Arial" panose="020B0604020202020204" pitchFamily="34" charset="0"/>
+              </a:rPr>
+              <a:t>US Hospital Participation in Health Information Networks</a:t>
+            </a:r>
+            <a:r>
+              <a:rPr kumimoji="0" lang="en-US" altLang="en-US" sz="1800" b="1" i="0" u="none" strike="noStrike" cap="none" normalizeH="0" baseline="0" dirty="0">
+                <a:ln>
+                  <a:noFill/>
+                </a:ln>
+                <a:solidFill>
+                  <a:schemeClr val="tx1"/>
+                </a:solidFill>
+                <a:effectLst/>
+                <a:latin typeface="Arial" panose="020B0604020202020204" pitchFamily="34" charset="0"/>
+              </a:rPr>
+              <a:t> [data set]. 2026. </a:t>
+            </a:r>
+          </a:p>
+          <a:p>
+            <a:pPr marL="342900" marR="0" lvl="0" indent="-342900" algn="l" defTabSz="914400" rtl="0" eaLnBrk="0" fontAlgn="base" latinLnBrk="0" hangingPunct="0">
+              <a:lnSpc>
+                <a:spcPct val="100000"/>
+              </a:lnSpc>
+              <a:spcBef>
+                <a:spcPct val="0"/>
+              </a:spcBef>
+              <a:spcAft>
+                <a:spcPct val="0"/>
+              </a:spcAft>
+              <a:buClrTx/>
+              <a:buSzTx/>
+              <a:buFont typeface="+mj-lt"/>
+              <a:buAutoNum type="arabicPeriod"/>
+              <a:tabLst/>
+            </a:pPr>
+            <a:r>
+              <a:rPr kumimoji="0" lang="en-US" altLang="en-US" sz="1800" b="1" i="0" u="none" strike="noStrike" cap="none" normalizeH="0" baseline="0" dirty="0">
+                <a:ln>
+                  <a:noFill/>
+                </a:ln>
+                <a:solidFill>
+                  <a:schemeClr val="tx1"/>
+                </a:solidFill>
+                <a:effectLst/>
+                <a:latin typeface="Arial" panose="020B0604020202020204" pitchFamily="34" charset="0"/>
+              </a:rPr>
+              <a:t>CMS. </a:t>
+            </a:r>
+            <a:r>
+              <a:rPr kumimoji="0" lang="en-US" altLang="en-US" sz="1800" b="1" i="1" u="none" strike="noStrike" cap="none" normalizeH="0" baseline="0" dirty="0">
+                <a:ln>
+                  <a:noFill/>
+                </a:ln>
+                <a:solidFill>
+                  <a:schemeClr val="tx1"/>
+                </a:solidFill>
+                <a:effectLst/>
+                <a:latin typeface="Arial" panose="020B0604020202020204" pitchFamily="34" charset="0"/>
+              </a:rPr>
+              <a:t>Complications and Deaths—Hospital</a:t>
+            </a:r>
+            <a:r>
+              <a:rPr kumimoji="0" lang="en-US" altLang="en-US" sz="1800" b="1" i="0" u="none" strike="noStrike" cap="none" normalizeH="0" baseline="0" dirty="0">
+                <a:ln>
+                  <a:noFill/>
+                </a:ln>
+                <a:solidFill>
+                  <a:schemeClr val="tx1"/>
+                </a:solidFill>
+                <a:effectLst/>
+                <a:latin typeface="Arial" panose="020B0604020202020204" pitchFamily="34" charset="0"/>
+              </a:rPr>
+              <a:t> [data set]. 2026. </a:t>
+            </a:r>
+          </a:p>
+        </p:txBody>
+      </p:sp>
     </p:spTree>
   </p:cSld>
   <p:clrMapOvr>

</xml_diff>

<commit_message>
Clarify current TEFCA participation wording
</commit_message>
<xml_diff>
--- a/poster/BMI6313_TEFCA_Poster_Jordan_Pulaski.pptx
+++ b/poster/BMI6313_TEFCA_Poster_Jordan_Pulaski.pptx
@@ -236,12 +236,12 @@
   <pc:docChgLst>
     <pc:chgData name="Pulaski, Jordan A" userId="b59e5678-eb70-4bba-8605-0c3b286199fc" providerId="ADAL" clId="{ECF8852F-3FCF-4736-A5DC-07A8B6B99125}"/>
     <pc:docChg chg="undo redo custSel modSld">
-      <pc:chgData name="Pulaski, Jordan A" userId="b59e5678-eb70-4bba-8605-0c3b286199fc" providerId="ADAL" clId="{ECF8852F-3FCF-4736-A5DC-07A8B6B99125}" dt="2026-08-07T02:30:58.933" v="1257" actId="14100"/>
+      <pc:chgData name="Pulaski, Jordan A" userId="b59e5678-eb70-4bba-8605-0c3b286199fc" providerId="ADAL" clId="{ECF8852F-3FCF-4736-A5DC-07A8B6B99125}" dt="2026-08-07T08:55:23.097" v="1436" actId="20577"/>
       <pc:docMkLst>
         <pc:docMk/>
       </pc:docMkLst>
       <pc:sldChg chg="addSp delSp modSp mod">
-        <pc:chgData name="Pulaski, Jordan A" userId="b59e5678-eb70-4bba-8605-0c3b286199fc" providerId="ADAL" clId="{ECF8852F-3FCF-4736-A5DC-07A8B6B99125}" dt="2026-08-07T02:30:58.933" v="1257" actId="14100"/>
+        <pc:chgData name="Pulaski, Jordan A" userId="b59e5678-eb70-4bba-8605-0c3b286199fc" providerId="ADAL" clId="{ECF8852F-3FCF-4736-A5DC-07A8B6B99125}" dt="2026-08-07T08:55:23.097" v="1436" actId="20577"/>
         <pc:sldMkLst>
           <pc:docMk/>
           <pc:sldMk cId="0" sldId="256"/>
@@ -279,7 +279,7 @@
           </ac:spMkLst>
         </pc:spChg>
         <pc:spChg chg="mod">
-          <ac:chgData name="Pulaski, Jordan A" userId="b59e5678-eb70-4bba-8605-0c3b286199fc" providerId="ADAL" clId="{ECF8852F-3FCF-4736-A5DC-07A8B6B99125}" dt="2026-08-06T21:19:23.727" v="1171" actId="14100"/>
+          <ac:chgData name="Pulaski, Jordan A" userId="b59e5678-eb70-4bba-8605-0c3b286199fc" providerId="ADAL" clId="{ECF8852F-3FCF-4736-A5DC-07A8B6B99125}" dt="2026-08-07T08:52:38.810" v="1369" actId="20577"/>
           <ac:spMkLst>
             <pc:docMk/>
             <pc:sldMk cId="0" sldId="256"/>
@@ -295,7 +295,7 @@
           </ac:spMkLst>
         </pc:spChg>
         <pc:spChg chg="mod">
-          <ac:chgData name="Pulaski, Jordan A" userId="b59e5678-eb70-4bba-8605-0c3b286199fc" providerId="ADAL" clId="{ECF8852F-3FCF-4736-A5DC-07A8B6B99125}" dt="2026-08-06T20:25:00.223" v="1084" actId="1076"/>
+          <ac:chgData name="Pulaski, Jordan A" userId="b59e5678-eb70-4bba-8605-0c3b286199fc" providerId="ADAL" clId="{ECF8852F-3FCF-4736-A5DC-07A8B6B99125}" dt="2026-08-07T08:54:24.793" v="1423" actId="14100"/>
           <ac:spMkLst>
             <pc:docMk/>
             <pc:sldMk cId="0" sldId="256"/>
@@ -319,7 +319,7 @@
           </ac:spMkLst>
         </pc:spChg>
         <pc:spChg chg="mod">
-          <ac:chgData name="Pulaski, Jordan A" userId="b59e5678-eb70-4bba-8605-0c3b286199fc" providerId="ADAL" clId="{ECF8852F-3FCF-4736-A5DC-07A8B6B99125}" dt="2026-08-06T20:30:36.285" v="1137" actId="1076"/>
+          <ac:chgData name="Pulaski, Jordan A" userId="b59e5678-eb70-4bba-8605-0c3b286199fc" providerId="ADAL" clId="{ECF8852F-3FCF-4736-A5DC-07A8B6B99125}" dt="2026-08-07T08:54:33.076" v="1424" actId="1076"/>
           <ac:spMkLst>
             <pc:docMk/>
             <pc:sldMk cId="0" sldId="256"/>
@@ -327,7 +327,7 @@
           </ac:spMkLst>
         </pc:spChg>
         <pc:spChg chg="mod">
-          <ac:chgData name="Pulaski, Jordan A" userId="b59e5678-eb70-4bba-8605-0c3b286199fc" providerId="ADAL" clId="{ECF8852F-3FCF-4736-A5DC-07A8B6B99125}" dt="2026-08-06T21:19:39.755" v="1181" actId="12"/>
+          <ac:chgData name="Pulaski, Jordan A" userId="b59e5678-eb70-4bba-8605-0c3b286199fc" providerId="ADAL" clId="{ECF8852F-3FCF-4736-A5DC-07A8B6B99125}" dt="2026-08-07T08:55:11.708" v="1428"/>
           <ac:spMkLst>
             <pc:docMk/>
             <pc:sldMk cId="0" sldId="256"/>
@@ -335,7 +335,7 @@
           </ac:spMkLst>
         </pc:spChg>
         <pc:spChg chg="mod">
-          <ac:chgData name="Pulaski, Jordan A" userId="b59e5678-eb70-4bba-8605-0c3b286199fc" providerId="ADAL" clId="{ECF8852F-3FCF-4736-A5DC-07A8B6B99125}" dt="2026-08-06T20:32:34.961" v="1156" actId="20577"/>
+          <ac:chgData name="Pulaski, Jordan A" userId="b59e5678-eb70-4bba-8605-0c3b286199fc" providerId="ADAL" clId="{ECF8852F-3FCF-4736-A5DC-07A8B6B99125}" dt="2026-08-07T08:54:19.385" v="1422" actId="14100"/>
           <ac:spMkLst>
             <pc:docMk/>
             <pc:sldMk cId="0" sldId="256"/>
@@ -391,7 +391,7 @@
           </ac:spMkLst>
         </pc:spChg>
         <pc:spChg chg="mod">
-          <ac:chgData name="Pulaski, Jordan A" userId="b59e5678-eb70-4bba-8605-0c3b286199fc" providerId="ADAL" clId="{ECF8852F-3FCF-4736-A5DC-07A8B6B99125}" dt="2026-08-06T20:30:45.276" v="1139" actId="1076"/>
+          <ac:chgData name="Pulaski, Jordan A" userId="b59e5678-eb70-4bba-8605-0c3b286199fc" providerId="ADAL" clId="{ECF8852F-3FCF-4736-A5DC-07A8B6B99125}" dt="2026-08-07T08:55:23.097" v="1436" actId="20577"/>
           <ac:spMkLst>
             <pc:docMk/>
             <pc:sldMk cId="0" sldId="256"/>
@@ -399,7 +399,7 @@
           </ac:spMkLst>
         </pc:spChg>
         <pc:spChg chg="mod">
-          <ac:chgData name="Pulaski, Jordan A" userId="b59e5678-eb70-4bba-8605-0c3b286199fc" providerId="ADAL" clId="{ECF8852F-3FCF-4736-A5DC-07A8B6B99125}" dt="2026-08-04T23:07:38.296" v="849" actId="1076"/>
+          <ac:chgData name="Pulaski, Jordan A" userId="b59e5678-eb70-4bba-8605-0c3b286199fc" providerId="ADAL" clId="{ECF8852F-3FCF-4736-A5DC-07A8B6B99125}" dt="2026-08-07T08:54:08.455" v="1421" actId="14100"/>
           <ac:spMkLst>
             <pc:docMk/>
             <pc:sldMk cId="0" sldId="256"/>
@@ -455,7 +455,7 @@
           </ac:spMkLst>
         </pc:spChg>
         <pc:spChg chg="mod">
-          <ac:chgData name="Pulaski, Jordan A" userId="b59e5678-eb70-4bba-8605-0c3b286199fc" providerId="ADAL" clId="{ECF8852F-3FCF-4736-A5DC-07A8B6B99125}" dt="2026-08-06T20:30:26.350" v="1136" actId="14100"/>
+          <ac:chgData name="Pulaski, Jordan A" userId="b59e5678-eb70-4bba-8605-0c3b286199fc" providerId="ADAL" clId="{ECF8852F-3FCF-4736-A5DC-07A8B6B99125}" dt="2026-08-07T08:51:25.833" v="1287" actId="14100"/>
           <ac:spMkLst>
             <pc:docMk/>
             <pc:sldMk cId="0" sldId="256"/>
@@ -4838,8 +4838,8 @@
         </p:nvSpPr>
         <p:spPr bwMode="auto">
           <a:xfrm>
-            <a:off x="29285716" y="5100825"/>
-            <a:ext cx="13790811" cy="803894"/>
+            <a:off x="29625700" y="5110658"/>
+            <a:ext cx="13432915" cy="803894"/>
           </a:xfrm>
           <a:prstGeom prst="rect">
             <a:avLst/>
@@ -4896,8 +4896,8 @@
         </p:nvSpPr>
         <p:spPr bwMode="auto">
           <a:xfrm>
-            <a:off x="29352242" y="5885081"/>
-            <a:ext cx="6749613" cy="7165333"/>
+            <a:off x="29718000" y="6000340"/>
+            <a:ext cx="6672819" cy="7165333"/>
           </a:xfrm>
           <a:prstGeom prst="rect">
             <a:avLst/>
@@ -5009,7 +5009,7 @@
                 <a:latin typeface="Arial" pitchFamily="34" charset="0"/>
                 <a:cs typeface="Arial" pitchFamily="34" charset="0"/>
               </a:rPr>
-              <a:t>In the adjusted primary model:  current participation associated with 0.108-point higher Hybrid HWM score than planned participation (95% CI, 0.001–0.216; </a:t>
+              <a:t>In the adjusted primary model, current participation was associated with a 0.108-point higher Hybrid HWM score than planned participation (95% CI, 0.001–0.216; </a:t>
             </a:r>
             <a:r>
               <a:rPr lang="en-US" sz="3400" i="1" dirty="0">
@@ -5039,7 +5039,7 @@
         <p:spPr bwMode="auto">
           <a:xfrm>
             <a:off x="223625" y="5089573"/>
-            <a:ext cx="13786253" cy="794358"/>
+            <a:ext cx="13807777" cy="794358"/>
           </a:xfrm>
           <a:prstGeom prst="rect">
             <a:avLst/>
@@ -5089,7 +5089,7 @@
         <p:spPr bwMode="auto">
           <a:xfrm>
             <a:off x="14263394" y="5096746"/>
-            <a:ext cx="14768806" cy="794358"/>
+            <a:ext cx="14983096" cy="794358"/>
           </a:xfrm>
           <a:prstGeom prst="rect">
             <a:avLst/>
@@ -5147,7 +5147,7 @@
         <p:spPr bwMode="auto">
           <a:xfrm>
             <a:off x="14263394" y="10656283"/>
-            <a:ext cx="15032322" cy="4333789"/>
+            <a:ext cx="14983097" cy="4333789"/>
           </a:xfrm>
           <a:prstGeom prst="rect">
             <a:avLst/>
@@ -5225,7 +5225,7 @@
                 <a:latin typeface="Arial" pitchFamily="34" charset="0"/>
                 <a:cs typeface="Arial" pitchFamily="34" charset="0"/>
               </a:rPr>
-              <a:t> Adjusted OLS models compared current and neither status with planned participation, controlling for national network, EHR vendor network, and HIO participation, log CMS denominator (total eligible patient population), state, and survey year. </a:t>
+              <a:t> Adjusted OLS models compared current TEFCA and neither-current-nor-planned TEFCA hospitals with planned hospitals, controlling for national network, EHR vendor network, and HIO participation, log CMS denominator (total eligible patient population), state, and survey year. </a:t>
             </a:r>
             <a:r>
               <a:rPr lang="en-US" sz="2700" i="1" dirty="0">
@@ -5371,7 +5371,7 @@
         <p:spPr bwMode="auto">
           <a:xfrm>
             <a:off x="258627" y="5792339"/>
-            <a:ext cx="13751251" cy="7426943"/>
+            <a:ext cx="13807777" cy="7426943"/>
           </a:xfrm>
           <a:prstGeom prst="rect">
             <a:avLst/>
@@ -5456,7 +5456,7 @@
                 <a:latin typeface="Arial" pitchFamily="34" charset="0"/>
                 <a:cs typeface="Arial" pitchFamily="34" charset="0"/>
               </a:rPr>
-              <a:t>Determine whether U.S. non-federal acute care hospitals participating in TEFCA, versus hospitals planning to participate, were associated with lower mortality. The primary outcome was CMS Hybrid Hospital-Wide Mortality (Hybrid HWM); heart failure and pneumonia mortality were secondary outcomes</a:t>
+              <a:t>Determine whether U.S. non-federal acute care hospitals participating in TEFCA (current), versus hospitals with planned participation (planned), were associated with lower mortality. The primary outcome was CMS Hybrid Hospital-Wide Mortality (Hybrid HWM); heart failure and pneumonia mortality were secondary outcomes</a:t>
             </a:r>
           </a:p>
         </p:txBody>
@@ -6985,8 +6985,8 @@
         </p:nvSpPr>
         <p:spPr>
           <a:xfrm>
-            <a:off x="36410068" y="5970427"/>
-            <a:ext cx="6749612" cy="6894195"/>
+            <a:off x="36804600" y="5970427"/>
+            <a:ext cx="6355080" cy="7417415"/>
           </a:xfrm>
           <a:prstGeom prst="rect">
             <a:avLst/>
@@ -7037,7 +7037,7 @@
             </a:r>
             <a:r>
               <a:rPr lang="en-US" sz="3400" dirty="0"/>
-              <a:t> = .114). Participation in EHR vendor networks and larger CMS denominators associated with lower Hybrid HWM scores.</a:t>
+              <a:t> = .114). Participation in EHR vendor networks and larger CMS denominators was associated with lower Hybrid HWM scores.</a:t>
             </a:r>
           </a:p>
         </p:txBody>
@@ -7056,8 +7056,8 @@
         </p:nvSpPr>
         <p:spPr>
           <a:xfrm>
-            <a:off x="29308416" y="13290632"/>
-            <a:ext cx="13790811" cy="1477328"/>
+            <a:off x="29643612" y="13290632"/>
+            <a:ext cx="13455615" cy="1477328"/>
           </a:xfrm>
           <a:prstGeom prst="rect">
             <a:avLst/>

</xml_diff>